<commit_message>
changed some files and 3rd pauls
</commit_message>
<xml_diff>
--- a/church/church ppts/sermon/3rd missionary journey/pauls3rd.pptx
+++ b/church/church ppts/sermon/3rd missionary journey/pauls3rd.pptx
@@ -299,7 +299,7 @@
           <a:p>
             <a:fld id="{BC695041-2FC5-4DA0-9DD8-242C72FB0FA9}" type="datetimeFigureOut">
               <a:rPr lang="en-IN" smtClean="0"/>
-              <a:t>18-07-2026</a:t>
+              <a:t>01-08-2026</a:t>
             </a:fld>
             <a:endParaRPr lang="en-IN"/>
           </a:p>
@@ -574,7 +574,7 @@
           <a:p>
             <a:fld id="{BC695041-2FC5-4DA0-9DD8-242C72FB0FA9}" type="datetimeFigureOut">
               <a:rPr lang="en-IN" smtClean="0"/>
-              <a:t>18-07-2026</a:t>
+              <a:t>01-08-2026</a:t>
             </a:fld>
             <a:endParaRPr lang="en-IN"/>
           </a:p>
@@ -768,7 +768,7 @@
           <a:p>
             <a:fld id="{BC695041-2FC5-4DA0-9DD8-242C72FB0FA9}" type="datetimeFigureOut">
               <a:rPr lang="en-IN" smtClean="0"/>
-              <a:t>18-07-2026</a:t>
+              <a:t>01-08-2026</a:t>
             </a:fld>
             <a:endParaRPr lang="en-IN"/>
           </a:p>
@@ -1041,7 +1041,7 @@
           <a:p>
             <a:fld id="{BC695041-2FC5-4DA0-9DD8-242C72FB0FA9}" type="datetimeFigureOut">
               <a:rPr lang="en-IN" smtClean="0"/>
-              <a:t>18-07-2026</a:t>
+              <a:t>01-08-2026</a:t>
             </a:fld>
             <a:endParaRPr lang="en-IN"/>
           </a:p>
@@ -1382,7 +1382,7 @@
           <a:p>
             <a:fld id="{BC695041-2FC5-4DA0-9DD8-242C72FB0FA9}" type="datetimeFigureOut">
               <a:rPr lang="en-IN" smtClean="0"/>
-              <a:t>18-07-2026</a:t>
+              <a:t>01-08-2026</a:t>
             </a:fld>
             <a:endParaRPr lang="en-IN"/>
           </a:p>
@@ -2005,7 +2005,7 @@
           <a:p>
             <a:fld id="{BC695041-2FC5-4DA0-9DD8-242C72FB0FA9}" type="datetimeFigureOut">
               <a:rPr lang="en-IN" smtClean="0"/>
-              <a:t>18-07-2026</a:t>
+              <a:t>01-08-2026</a:t>
             </a:fld>
             <a:endParaRPr lang="en-IN"/>
           </a:p>
@@ -2865,7 +2865,7 @@
           <a:p>
             <a:fld id="{BC695041-2FC5-4DA0-9DD8-242C72FB0FA9}" type="datetimeFigureOut">
               <a:rPr lang="en-IN" smtClean="0"/>
-              <a:t>18-07-2026</a:t>
+              <a:t>01-08-2026</a:t>
             </a:fld>
             <a:endParaRPr lang="en-IN"/>
           </a:p>
@@ -3035,7 +3035,7 @@
           <a:p>
             <a:fld id="{BC695041-2FC5-4DA0-9DD8-242C72FB0FA9}" type="datetimeFigureOut">
               <a:rPr lang="en-IN" smtClean="0"/>
-              <a:t>18-07-2026</a:t>
+              <a:t>01-08-2026</a:t>
             </a:fld>
             <a:endParaRPr lang="en-IN"/>
           </a:p>
@@ -3215,7 +3215,7 @@
           <a:p>
             <a:fld id="{BC695041-2FC5-4DA0-9DD8-242C72FB0FA9}" type="datetimeFigureOut">
               <a:rPr lang="en-IN" smtClean="0"/>
-              <a:t>18-07-2026</a:t>
+              <a:t>01-08-2026</a:t>
             </a:fld>
             <a:endParaRPr lang="en-IN"/>
           </a:p>
@@ -3385,7 +3385,7 @@
           <a:p>
             <a:fld id="{BC695041-2FC5-4DA0-9DD8-242C72FB0FA9}" type="datetimeFigureOut">
               <a:rPr lang="en-IN" smtClean="0"/>
-              <a:t>18-07-2026</a:t>
+              <a:t>01-08-2026</a:t>
             </a:fld>
             <a:endParaRPr lang="en-IN"/>
           </a:p>
@@ -3632,7 +3632,7 @@
           <a:p>
             <a:fld id="{BC695041-2FC5-4DA0-9DD8-242C72FB0FA9}" type="datetimeFigureOut">
               <a:rPr lang="en-IN" smtClean="0"/>
-              <a:t>18-07-2026</a:t>
+              <a:t>01-08-2026</a:t>
             </a:fld>
             <a:endParaRPr lang="en-IN"/>
           </a:p>
@@ -3924,7 +3924,7 @@
           <a:p>
             <a:fld id="{BC695041-2FC5-4DA0-9DD8-242C72FB0FA9}" type="datetimeFigureOut">
               <a:rPr lang="en-IN" smtClean="0"/>
-              <a:t>18-07-2026</a:t>
+              <a:t>01-08-2026</a:t>
             </a:fld>
             <a:endParaRPr lang="en-IN"/>
           </a:p>
@@ -4368,7 +4368,7 @@
           <a:p>
             <a:fld id="{BC695041-2FC5-4DA0-9DD8-242C72FB0FA9}" type="datetimeFigureOut">
               <a:rPr lang="en-IN" smtClean="0"/>
-              <a:t>18-07-2026</a:t>
+              <a:t>01-08-2026</a:t>
             </a:fld>
             <a:endParaRPr lang="en-IN"/>
           </a:p>
@@ -4486,7 +4486,7 @@
           <a:p>
             <a:fld id="{BC695041-2FC5-4DA0-9DD8-242C72FB0FA9}" type="datetimeFigureOut">
               <a:rPr lang="en-IN" smtClean="0"/>
-              <a:t>18-07-2026</a:t>
+              <a:t>01-08-2026</a:t>
             </a:fld>
             <a:endParaRPr lang="en-IN"/>
           </a:p>
@@ -4581,7 +4581,7 @@
           <a:p>
             <a:fld id="{BC695041-2FC5-4DA0-9DD8-242C72FB0FA9}" type="datetimeFigureOut">
               <a:rPr lang="en-IN" smtClean="0"/>
-              <a:t>18-07-2026</a:t>
+              <a:t>01-08-2026</a:t>
             </a:fld>
             <a:endParaRPr lang="en-IN"/>
           </a:p>
@@ -4860,7 +4860,7 @@
           <a:p>
             <a:fld id="{BC695041-2FC5-4DA0-9DD8-242C72FB0FA9}" type="datetimeFigureOut">
               <a:rPr lang="en-IN" smtClean="0"/>
-              <a:t>18-07-2026</a:t>
+              <a:t>01-08-2026</a:t>
             </a:fld>
             <a:endParaRPr lang="en-IN"/>
           </a:p>
@@ -5135,7 +5135,7 @@
           <a:p>
             <a:fld id="{BC695041-2FC5-4DA0-9DD8-242C72FB0FA9}" type="datetimeFigureOut">
               <a:rPr lang="en-IN" smtClean="0"/>
-              <a:t>18-07-2026</a:t>
+              <a:t>01-08-2026</a:t>
             </a:fld>
             <a:endParaRPr lang="en-IN"/>
           </a:p>
@@ -5564,7 +5564,7 @@
           <a:p>
             <a:fld id="{BC695041-2FC5-4DA0-9DD8-242C72FB0FA9}" type="datetimeFigureOut">
               <a:rPr lang="en-IN" smtClean="0"/>
-              <a:t>18-07-2026</a:t>
+              <a:t>01-08-2026</a:t>
             </a:fld>
             <a:endParaRPr lang="en-IN"/>
           </a:p>
@@ -6568,7 +6568,7 @@
         <p:spPr>
           <a:xfrm>
             <a:off x="410198" y="6071343"/>
-            <a:ext cx="10772501" cy="400110"/>
+            <a:ext cx="7487947" cy="400110"/>
           </a:xfrm>
           <a:prstGeom prst="rect">
             <a:avLst/>
@@ -6622,20 +6622,12 @@
               <a:t>മിഷനറി </a:t>
             </a:r>
             <a:r>
-              <a:rPr lang="ml-IN" sz="2000" b="1" u="sng" dirty="0">
-                <a:solidFill>
-                  <a:schemeClr val="bg1"/>
-                </a:solidFill>
-              </a:rPr>
-              <a:t>യാത്ര</a:t>
-            </a:r>
-            <a:r>
               <a:rPr lang="ml-IN" sz="2000" b="1" u="sng" dirty="0" smtClean="0">
                 <a:solidFill>
                   <a:schemeClr val="bg1"/>
                 </a:solidFill>
               </a:rPr>
-              <a:t> (ഏകദേശം ക്രി.വ. 49-52) </a:t>
+              <a:t>യാത്ര </a:t>
             </a:r>
             <a:endParaRPr lang="en-IN" sz="2000" b="1" u="sng" dirty="0">
               <a:solidFill>
@@ -6746,6 +6738,2120 @@
               <a:schemeClr val="accent1"/>
             </a:solidFill>
           </a:ln>
+        </p:spPr>
+        <p:style>
+          <a:lnRef idx="2">
+            <a:schemeClr val="accent1">
+              <a:shade val="50000"/>
+            </a:schemeClr>
+          </a:lnRef>
+          <a:fillRef idx="1">
+            <a:schemeClr val="accent1"/>
+          </a:fillRef>
+          <a:effectRef idx="0">
+            <a:schemeClr val="accent1"/>
+          </a:effectRef>
+          <a:fontRef idx="minor">
+            <a:schemeClr val="lt1"/>
+          </a:fontRef>
+        </p:style>
+        <p:txBody>
+          <a:bodyPr rtlCol="0" anchor="ctr"/>
+          <a:lstStyle/>
+          <a:p>
+            <a:pPr algn="ctr"/>
+            <a:endParaRPr lang="en-IN"/>
+          </a:p>
+        </p:txBody>
+      </p:sp>
+      <p:cxnSp>
+        <p:nvCxnSpPr>
+          <p:cNvPr id="16" name="Straight Arrow Connector 15"/>
+          <p:cNvCxnSpPr/>
+          <p:nvPr/>
+        </p:nvCxnSpPr>
+        <p:spPr>
+          <a:xfrm flipH="1" flipV="1">
+            <a:off x="3216467" y="1304978"/>
+            <a:ext cx="1017471" cy="538882"/>
+          </a:xfrm>
+          <a:prstGeom prst="straightConnector1">
+            <a:avLst/>
+          </a:prstGeom>
+          <a:ln w="76200">
+            <a:tailEnd type="triangle"/>
+          </a:ln>
+        </p:spPr>
+        <p:style>
+          <a:lnRef idx="1">
+            <a:schemeClr val="accent1"/>
+          </a:lnRef>
+          <a:fillRef idx="0">
+            <a:schemeClr val="accent1"/>
+          </a:fillRef>
+          <a:effectRef idx="0">
+            <a:schemeClr val="accent1"/>
+          </a:effectRef>
+          <a:fontRef idx="minor">
+            <a:schemeClr val="tx1"/>
+          </a:fontRef>
+        </p:style>
+      </p:cxnSp>
+      <p:sp>
+        <p:nvSpPr>
+          <p:cNvPr id="18" name="Right Arrow 17"/>
+          <p:cNvSpPr/>
+          <p:nvPr/>
+        </p:nvSpPr>
+        <p:spPr>
+          <a:xfrm rot="12049014">
+            <a:off x="3025313" y="1175659"/>
+            <a:ext cx="162607" cy="190524"/>
+          </a:xfrm>
+          <a:prstGeom prst="rightArrow">
+            <a:avLst/>
+          </a:prstGeom>
+        </p:spPr>
+        <p:style>
+          <a:lnRef idx="2">
+            <a:schemeClr val="accent1">
+              <a:shade val="50000"/>
+            </a:schemeClr>
+          </a:lnRef>
+          <a:fillRef idx="1">
+            <a:schemeClr val="accent1"/>
+          </a:fillRef>
+          <a:effectRef idx="0">
+            <a:schemeClr val="accent1"/>
+          </a:effectRef>
+          <a:fontRef idx="minor">
+            <a:schemeClr val="lt1"/>
+          </a:fontRef>
+        </p:style>
+        <p:txBody>
+          <a:bodyPr rtlCol="0" anchor="ctr"/>
+          <a:lstStyle/>
+          <a:p>
+            <a:pPr algn="ctr"/>
+            <a:endParaRPr lang="en-IN"/>
+          </a:p>
+        </p:txBody>
+      </p:sp>
+      <p:cxnSp>
+        <p:nvCxnSpPr>
+          <p:cNvPr id="19" name="Straight Arrow Connector 18"/>
+          <p:cNvCxnSpPr/>
+          <p:nvPr/>
+        </p:nvCxnSpPr>
+        <p:spPr>
+          <a:xfrm flipH="1">
+            <a:off x="2220380" y="1152983"/>
+            <a:ext cx="776384" cy="282622"/>
+          </a:xfrm>
+          <a:prstGeom prst="straightConnector1">
+            <a:avLst/>
+          </a:prstGeom>
+          <a:ln w="76200">
+            <a:tailEnd type="triangle"/>
+          </a:ln>
+        </p:spPr>
+        <p:style>
+          <a:lnRef idx="1">
+            <a:schemeClr val="accent1"/>
+          </a:lnRef>
+          <a:fillRef idx="0">
+            <a:schemeClr val="accent1"/>
+          </a:fillRef>
+          <a:effectRef idx="0">
+            <a:schemeClr val="accent1"/>
+          </a:effectRef>
+          <a:fontRef idx="minor">
+            <a:schemeClr val="tx1"/>
+          </a:fontRef>
+        </p:style>
+      </p:cxnSp>
+      <p:sp>
+        <p:nvSpPr>
+          <p:cNvPr id="24" name="Right Arrow 23"/>
+          <p:cNvSpPr/>
+          <p:nvPr/>
+        </p:nvSpPr>
+        <p:spPr>
+          <a:xfrm rot="8970105">
+            <a:off x="1928997" y="1440160"/>
+            <a:ext cx="273542" cy="144874"/>
+          </a:xfrm>
+          <a:prstGeom prst="rightArrow">
+            <a:avLst/>
+          </a:prstGeom>
+        </p:spPr>
+        <p:style>
+          <a:lnRef idx="2">
+            <a:schemeClr val="accent1">
+              <a:shade val="50000"/>
+            </a:schemeClr>
+          </a:lnRef>
+          <a:fillRef idx="1">
+            <a:schemeClr val="accent1"/>
+          </a:fillRef>
+          <a:effectRef idx="0">
+            <a:schemeClr val="accent1"/>
+          </a:effectRef>
+          <a:fontRef idx="minor">
+            <a:schemeClr val="lt1"/>
+          </a:fontRef>
+        </p:style>
+        <p:txBody>
+          <a:bodyPr rtlCol="0" anchor="ctr"/>
+          <a:lstStyle/>
+          <a:p>
+            <a:pPr algn="ctr"/>
+            <a:endParaRPr lang="en-IN"/>
+          </a:p>
+        </p:txBody>
+      </p:sp>
+      <p:sp>
+        <p:nvSpPr>
+          <p:cNvPr id="22" name="Freeform 21"/>
+          <p:cNvSpPr/>
+          <p:nvPr/>
+        </p:nvSpPr>
+        <p:spPr>
+          <a:xfrm>
+            <a:off x="1914258" y="1640793"/>
+            <a:ext cx="298443" cy="1307506"/>
+          </a:xfrm>
+          <a:custGeom>
+            <a:avLst/>
+            <a:gdLst>
+              <a:gd name="connsiteX0" fmla="*/ 0 w 298443"/>
+              <a:gd name="connsiteY0" fmla="*/ 0 h 1307506"/>
+              <a:gd name="connsiteX1" fmla="*/ 290557 w 298443"/>
+              <a:gd name="connsiteY1" fmla="*/ 991312 h 1307506"/>
+              <a:gd name="connsiteX2" fmla="*/ 222191 w 298443"/>
+              <a:gd name="connsiteY2" fmla="*/ 1307506 h 1307506"/>
+              <a:gd name="connsiteX3" fmla="*/ 222191 w 298443"/>
+              <a:gd name="connsiteY3" fmla="*/ 1307506 h 1307506"/>
+              <a:gd name="connsiteX4" fmla="*/ 222191 w 298443"/>
+              <a:gd name="connsiteY4" fmla="*/ 1307506 h 1307506"/>
+            </a:gdLst>
+            <a:ahLst/>
+            <a:cxnLst>
+              <a:cxn ang="0">
+                <a:pos x="connsiteX0" y="connsiteY0"/>
+              </a:cxn>
+              <a:cxn ang="0">
+                <a:pos x="connsiteX1" y="connsiteY1"/>
+              </a:cxn>
+              <a:cxn ang="0">
+                <a:pos x="connsiteX2" y="connsiteY2"/>
+              </a:cxn>
+              <a:cxn ang="0">
+                <a:pos x="connsiteX3" y="connsiteY3"/>
+              </a:cxn>
+              <a:cxn ang="0">
+                <a:pos x="connsiteX4" y="connsiteY4"/>
+              </a:cxn>
+            </a:cxnLst>
+            <a:rect l="l" t="t" r="r" b="b"/>
+            <a:pathLst>
+              <a:path w="298443" h="1307506">
+                <a:moveTo>
+                  <a:pt x="0" y="0"/>
+                </a:moveTo>
+                <a:cubicBezTo>
+                  <a:pt x="126762" y="386697"/>
+                  <a:pt x="253525" y="773394"/>
+                  <a:pt x="290557" y="991312"/>
+                </a:cubicBezTo>
+                <a:cubicBezTo>
+                  <a:pt x="327589" y="1209230"/>
+                  <a:pt x="222191" y="1307506"/>
+                  <a:pt x="222191" y="1307506"/>
+                </a:cubicBezTo>
+                <a:lnTo>
+                  <a:pt x="222191" y="1307506"/>
+                </a:lnTo>
+                <a:lnTo>
+                  <a:pt x="222191" y="1307506"/>
+                </a:lnTo>
+              </a:path>
+            </a:pathLst>
+          </a:custGeom>
+          <a:noFill/>
+          <a:ln w="76200"/>
+        </p:spPr>
+        <p:style>
+          <a:lnRef idx="2">
+            <a:schemeClr val="accent1">
+              <a:shade val="50000"/>
+            </a:schemeClr>
+          </a:lnRef>
+          <a:fillRef idx="1">
+            <a:schemeClr val="accent1"/>
+          </a:fillRef>
+          <a:effectRef idx="0">
+            <a:schemeClr val="accent1"/>
+          </a:effectRef>
+          <a:fontRef idx="minor">
+            <a:schemeClr val="lt1"/>
+          </a:fontRef>
+        </p:style>
+        <p:txBody>
+          <a:bodyPr rtlCol="0" anchor="ctr"/>
+          <a:lstStyle/>
+          <a:p>
+            <a:pPr algn="ctr"/>
+            <a:endParaRPr lang="en-IN"/>
+          </a:p>
+        </p:txBody>
+      </p:sp>
+      <p:sp>
+        <p:nvSpPr>
+          <p:cNvPr id="25" name="Freeform 24"/>
+          <p:cNvSpPr/>
+          <p:nvPr/>
+        </p:nvSpPr>
+        <p:spPr>
+          <a:xfrm>
+            <a:off x="2025353" y="1692067"/>
+            <a:ext cx="414525" cy="1281869"/>
+          </a:xfrm>
+          <a:custGeom>
+            <a:avLst/>
+            <a:gdLst>
+              <a:gd name="connsiteX0" fmla="*/ 179462 w 414525"/>
+              <a:gd name="connsiteY0" fmla="*/ 1281869 h 1281869"/>
+              <a:gd name="connsiteX1" fmla="*/ 410198 w 414525"/>
+              <a:gd name="connsiteY1" fmla="*/ 521294 h 1281869"/>
+              <a:gd name="connsiteX2" fmla="*/ 0 w 414525"/>
+              <a:gd name="connsiteY2" fmla="*/ 0 h 1281869"/>
+              <a:gd name="connsiteX3" fmla="*/ 0 w 414525"/>
+              <a:gd name="connsiteY3" fmla="*/ 0 h 1281869"/>
+              <a:gd name="connsiteX4" fmla="*/ 0 w 414525"/>
+              <a:gd name="connsiteY4" fmla="*/ 0 h 1281869"/>
+              <a:gd name="connsiteX5" fmla="*/ 0 w 414525"/>
+              <a:gd name="connsiteY5" fmla="*/ 0 h 1281869"/>
+              <a:gd name="connsiteX6" fmla="*/ 0 w 414525"/>
+              <a:gd name="connsiteY6" fmla="*/ 0 h 1281869"/>
+            </a:gdLst>
+            <a:ahLst/>
+            <a:cxnLst>
+              <a:cxn ang="0">
+                <a:pos x="connsiteX0" y="connsiteY0"/>
+              </a:cxn>
+              <a:cxn ang="0">
+                <a:pos x="connsiteX1" y="connsiteY1"/>
+              </a:cxn>
+              <a:cxn ang="0">
+                <a:pos x="connsiteX2" y="connsiteY2"/>
+              </a:cxn>
+              <a:cxn ang="0">
+                <a:pos x="connsiteX3" y="connsiteY3"/>
+              </a:cxn>
+              <a:cxn ang="0">
+                <a:pos x="connsiteX4" y="connsiteY4"/>
+              </a:cxn>
+              <a:cxn ang="0">
+                <a:pos x="connsiteX5" y="connsiteY5"/>
+              </a:cxn>
+              <a:cxn ang="0">
+                <a:pos x="connsiteX6" y="connsiteY6"/>
+              </a:cxn>
+            </a:cxnLst>
+            <a:rect l="l" t="t" r="r" b="b"/>
+            <a:pathLst>
+              <a:path w="414525" h="1281869">
+                <a:moveTo>
+                  <a:pt x="179462" y="1281869"/>
+                </a:moveTo>
+                <a:cubicBezTo>
+                  <a:pt x="309785" y="1008404"/>
+                  <a:pt x="440108" y="734939"/>
+                  <a:pt x="410198" y="521294"/>
+                </a:cubicBezTo>
+                <a:cubicBezTo>
+                  <a:pt x="380288" y="307649"/>
+                  <a:pt x="0" y="0"/>
+                  <a:pt x="0" y="0"/>
+                </a:cubicBezTo>
+                <a:lnTo>
+                  <a:pt x="0" y="0"/>
+                </a:lnTo>
+                <a:lnTo>
+                  <a:pt x="0" y="0"/>
+                </a:lnTo>
+                <a:lnTo>
+                  <a:pt x="0" y="0"/>
+                </a:lnTo>
+                <a:lnTo>
+                  <a:pt x="0" y="0"/>
+                </a:lnTo>
+              </a:path>
+            </a:pathLst>
+          </a:custGeom>
+          <a:noFill/>
+          <a:ln w="76200"/>
+        </p:spPr>
+        <p:style>
+          <a:lnRef idx="2">
+            <a:schemeClr val="accent1">
+              <a:shade val="50000"/>
+            </a:schemeClr>
+          </a:lnRef>
+          <a:fillRef idx="1">
+            <a:schemeClr val="accent1"/>
+          </a:fillRef>
+          <a:effectRef idx="0">
+            <a:schemeClr val="accent1"/>
+          </a:effectRef>
+          <a:fontRef idx="minor">
+            <a:schemeClr val="lt1"/>
+          </a:fontRef>
+        </p:style>
+        <p:txBody>
+          <a:bodyPr rtlCol="0" anchor="ctr"/>
+          <a:lstStyle/>
+          <a:p>
+            <a:pPr algn="ctr"/>
+            <a:endParaRPr lang="en-IN"/>
+          </a:p>
+        </p:txBody>
+      </p:sp>
+      <p:sp>
+        <p:nvSpPr>
+          <p:cNvPr id="28" name="Freeform 27"/>
+          <p:cNvSpPr/>
+          <p:nvPr/>
+        </p:nvSpPr>
+        <p:spPr>
+          <a:xfrm>
+            <a:off x="2025353" y="1563880"/>
+            <a:ext cx="230737" cy="102550"/>
+          </a:xfrm>
+          <a:custGeom>
+            <a:avLst/>
+            <a:gdLst>
+              <a:gd name="connsiteX0" fmla="*/ 0 w 230737"/>
+              <a:gd name="connsiteY0" fmla="*/ 102550 h 102550"/>
+              <a:gd name="connsiteX1" fmla="*/ 188008 w 230737"/>
+              <a:gd name="connsiteY1" fmla="*/ 76913 h 102550"/>
+              <a:gd name="connsiteX2" fmla="*/ 230737 w 230737"/>
+              <a:gd name="connsiteY2" fmla="*/ 0 h 102550"/>
+              <a:gd name="connsiteX3" fmla="*/ 230737 w 230737"/>
+              <a:gd name="connsiteY3" fmla="*/ 0 h 102550"/>
+              <a:gd name="connsiteX4" fmla="*/ 230737 w 230737"/>
+              <a:gd name="connsiteY4" fmla="*/ 0 h 102550"/>
+              <a:gd name="connsiteX5" fmla="*/ 230737 w 230737"/>
+              <a:gd name="connsiteY5" fmla="*/ 0 h 102550"/>
+            </a:gdLst>
+            <a:ahLst/>
+            <a:cxnLst>
+              <a:cxn ang="0">
+                <a:pos x="connsiteX0" y="connsiteY0"/>
+              </a:cxn>
+              <a:cxn ang="0">
+                <a:pos x="connsiteX1" y="connsiteY1"/>
+              </a:cxn>
+              <a:cxn ang="0">
+                <a:pos x="connsiteX2" y="connsiteY2"/>
+              </a:cxn>
+              <a:cxn ang="0">
+                <a:pos x="connsiteX3" y="connsiteY3"/>
+              </a:cxn>
+              <a:cxn ang="0">
+                <a:pos x="connsiteX4" y="connsiteY4"/>
+              </a:cxn>
+              <a:cxn ang="0">
+                <a:pos x="connsiteX5" y="connsiteY5"/>
+              </a:cxn>
+            </a:cxnLst>
+            <a:rect l="l" t="t" r="r" b="b"/>
+            <a:pathLst>
+              <a:path w="230737" h="102550">
+                <a:moveTo>
+                  <a:pt x="0" y="102550"/>
+                </a:moveTo>
+                <a:cubicBezTo>
+                  <a:pt x="74776" y="98277"/>
+                  <a:pt x="149552" y="94005"/>
+                  <a:pt x="188008" y="76913"/>
+                </a:cubicBezTo>
+                <a:cubicBezTo>
+                  <a:pt x="226464" y="59821"/>
+                  <a:pt x="230737" y="0"/>
+                  <a:pt x="230737" y="0"/>
+                </a:cubicBezTo>
+                <a:lnTo>
+                  <a:pt x="230737" y="0"/>
+                </a:lnTo>
+                <a:lnTo>
+                  <a:pt x="230737" y="0"/>
+                </a:lnTo>
+                <a:lnTo>
+                  <a:pt x="230737" y="0"/>
+                </a:lnTo>
+              </a:path>
+            </a:pathLst>
+          </a:custGeom>
+          <a:noFill/>
+          <a:ln w="76200"/>
+        </p:spPr>
+        <p:style>
+          <a:lnRef idx="2">
+            <a:schemeClr val="accent1">
+              <a:shade val="50000"/>
+            </a:schemeClr>
+          </a:lnRef>
+          <a:fillRef idx="1">
+            <a:schemeClr val="accent1"/>
+          </a:fillRef>
+          <a:effectRef idx="0">
+            <a:schemeClr val="accent1"/>
+          </a:effectRef>
+          <a:fontRef idx="minor">
+            <a:schemeClr val="lt1"/>
+          </a:fontRef>
+        </p:style>
+        <p:txBody>
+          <a:bodyPr rtlCol="0" anchor="ctr"/>
+          <a:lstStyle/>
+          <a:p>
+            <a:pPr algn="ctr"/>
+            <a:endParaRPr lang="en-IN"/>
+          </a:p>
+        </p:txBody>
+      </p:sp>
+      <p:sp>
+        <p:nvSpPr>
+          <p:cNvPr id="29" name="Freeform 28"/>
+          <p:cNvSpPr/>
+          <p:nvPr/>
+        </p:nvSpPr>
+        <p:spPr>
+          <a:xfrm>
+            <a:off x="2290273" y="1281869"/>
+            <a:ext cx="700755" cy="272051"/>
+          </a:xfrm>
+          <a:custGeom>
+            <a:avLst/>
+            <a:gdLst>
+              <a:gd name="connsiteX0" fmla="*/ 0 w 700755"/>
+              <a:gd name="connsiteY0" fmla="*/ 222191 h 272051"/>
+              <a:gd name="connsiteX1" fmla="*/ 504202 w 700755"/>
+              <a:gd name="connsiteY1" fmla="*/ 256374 h 272051"/>
+              <a:gd name="connsiteX2" fmla="*/ 700755 w 700755"/>
+              <a:gd name="connsiteY2" fmla="*/ 0 h 272051"/>
+              <a:gd name="connsiteX3" fmla="*/ 700755 w 700755"/>
+              <a:gd name="connsiteY3" fmla="*/ 0 h 272051"/>
+              <a:gd name="connsiteX4" fmla="*/ 700755 w 700755"/>
+              <a:gd name="connsiteY4" fmla="*/ 0 h 272051"/>
+              <a:gd name="connsiteX5" fmla="*/ 700755 w 700755"/>
+              <a:gd name="connsiteY5" fmla="*/ 0 h 272051"/>
+              <a:gd name="connsiteX6" fmla="*/ 700755 w 700755"/>
+              <a:gd name="connsiteY6" fmla="*/ 0 h 272051"/>
+            </a:gdLst>
+            <a:ahLst/>
+            <a:cxnLst>
+              <a:cxn ang="0">
+                <a:pos x="connsiteX0" y="connsiteY0"/>
+              </a:cxn>
+              <a:cxn ang="0">
+                <a:pos x="connsiteX1" y="connsiteY1"/>
+              </a:cxn>
+              <a:cxn ang="0">
+                <a:pos x="connsiteX2" y="connsiteY2"/>
+              </a:cxn>
+              <a:cxn ang="0">
+                <a:pos x="connsiteX3" y="connsiteY3"/>
+              </a:cxn>
+              <a:cxn ang="0">
+                <a:pos x="connsiteX4" y="connsiteY4"/>
+              </a:cxn>
+              <a:cxn ang="0">
+                <a:pos x="connsiteX5" y="connsiteY5"/>
+              </a:cxn>
+              <a:cxn ang="0">
+                <a:pos x="connsiteX6" y="connsiteY6"/>
+              </a:cxn>
+            </a:cxnLst>
+            <a:rect l="l" t="t" r="r" b="b"/>
+            <a:pathLst>
+              <a:path w="700755" h="272051">
+                <a:moveTo>
+                  <a:pt x="0" y="222191"/>
+                </a:moveTo>
+                <a:cubicBezTo>
+                  <a:pt x="193705" y="257798"/>
+                  <a:pt x="387410" y="293406"/>
+                  <a:pt x="504202" y="256374"/>
+                </a:cubicBezTo>
+                <a:cubicBezTo>
+                  <a:pt x="620994" y="219342"/>
+                  <a:pt x="700755" y="0"/>
+                  <a:pt x="700755" y="0"/>
+                </a:cubicBezTo>
+                <a:lnTo>
+                  <a:pt x="700755" y="0"/>
+                </a:lnTo>
+                <a:lnTo>
+                  <a:pt x="700755" y="0"/>
+                </a:lnTo>
+                <a:lnTo>
+                  <a:pt x="700755" y="0"/>
+                </a:lnTo>
+                <a:lnTo>
+                  <a:pt x="700755" y="0"/>
+                </a:lnTo>
+              </a:path>
+            </a:pathLst>
+          </a:custGeom>
+          <a:noFill/>
+          <a:ln w="76200"/>
+        </p:spPr>
+        <p:style>
+          <a:lnRef idx="2">
+            <a:schemeClr val="accent1">
+              <a:shade val="50000"/>
+            </a:schemeClr>
+          </a:lnRef>
+          <a:fillRef idx="1">
+            <a:schemeClr val="accent1"/>
+          </a:fillRef>
+          <a:effectRef idx="0">
+            <a:schemeClr val="accent1"/>
+          </a:effectRef>
+          <a:fontRef idx="minor">
+            <a:schemeClr val="lt1"/>
+          </a:fontRef>
+        </p:style>
+        <p:txBody>
+          <a:bodyPr rtlCol="0" anchor="ctr"/>
+          <a:lstStyle/>
+          <a:p>
+            <a:pPr algn="ctr"/>
+            <a:endParaRPr lang="en-IN"/>
+          </a:p>
+        </p:txBody>
+      </p:sp>
+      <p:sp>
+        <p:nvSpPr>
+          <p:cNvPr id="30" name="Right Arrow 29"/>
+          <p:cNvSpPr/>
+          <p:nvPr/>
+        </p:nvSpPr>
+        <p:spPr>
+          <a:xfrm rot="1155666">
+            <a:off x="2518112" y="1477397"/>
+            <a:ext cx="179364" cy="157427"/>
+          </a:xfrm>
+          <a:prstGeom prst="rightArrow">
+            <a:avLst/>
+          </a:prstGeom>
+        </p:spPr>
+        <p:style>
+          <a:lnRef idx="2">
+            <a:schemeClr val="accent1">
+              <a:shade val="50000"/>
+            </a:schemeClr>
+          </a:lnRef>
+          <a:fillRef idx="1">
+            <a:schemeClr val="accent1"/>
+          </a:fillRef>
+          <a:effectRef idx="0">
+            <a:schemeClr val="accent1"/>
+          </a:effectRef>
+          <a:fontRef idx="minor">
+            <a:schemeClr val="lt1"/>
+          </a:fontRef>
+        </p:style>
+        <p:txBody>
+          <a:bodyPr rtlCol="0" anchor="ctr"/>
+          <a:lstStyle/>
+          <a:p>
+            <a:pPr algn="ctr"/>
+            <a:endParaRPr lang="en-IN"/>
+          </a:p>
+        </p:txBody>
+      </p:sp>
+      <p:sp>
+        <p:nvSpPr>
+          <p:cNvPr id="32" name="Down Arrow 31"/>
+          <p:cNvSpPr/>
+          <p:nvPr/>
+        </p:nvSpPr>
+        <p:spPr>
+          <a:xfrm rot="20603570">
+            <a:off x="2006630" y="2070235"/>
+            <a:ext cx="199033" cy="292080"/>
+          </a:xfrm>
+          <a:prstGeom prst="downArrow">
+            <a:avLst/>
+          </a:prstGeom>
+        </p:spPr>
+        <p:style>
+          <a:lnRef idx="2">
+            <a:schemeClr val="accent1">
+              <a:shade val="50000"/>
+            </a:schemeClr>
+          </a:lnRef>
+          <a:fillRef idx="1">
+            <a:schemeClr val="accent1"/>
+          </a:fillRef>
+          <a:effectRef idx="0">
+            <a:schemeClr val="accent1"/>
+          </a:effectRef>
+          <a:fontRef idx="minor">
+            <a:schemeClr val="lt1"/>
+          </a:fontRef>
+        </p:style>
+        <p:txBody>
+          <a:bodyPr rtlCol="0" anchor="ctr"/>
+          <a:lstStyle/>
+          <a:p>
+            <a:pPr algn="ctr"/>
+            <a:endParaRPr lang="en-IN"/>
+          </a:p>
+        </p:txBody>
+      </p:sp>
+      <p:sp>
+        <p:nvSpPr>
+          <p:cNvPr id="33" name="Right Arrow 32"/>
+          <p:cNvSpPr/>
+          <p:nvPr/>
+        </p:nvSpPr>
+        <p:spPr>
+          <a:xfrm rot="14704838">
+            <a:off x="2284013" y="2015059"/>
+            <a:ext cx="235076" cy="189301"/>
+          </a:xfrm>
+          <a:prstGeom prst="rightArrow">
+            <a:avLst/>
+          </a:prstGeom>
+        </p:spPr>
+        <p:style>
+          <a:lnRef idx="2">
+            <a:schemeClr val="accent1">
+              <a:shade val="50000"/>
+            </a:schemeClr>
+          </a:lnRef>
+          <a:fillRef idx="1">
+            <a:schemeClr val="accent1"/>
+          </a:fillRef>
+          <a:effectRef idx="0">
+            <a:schemeClr val="accent1"/>
+          </a:effectRef>
+          <a:fontRef idx="minor">
+            <a:schemeClr val="lt1"/>
+          </a:fontRef>
+        </p:style>
+        <p:txBody>
+          <a:bodyPr rtlCol="0" anchor="ctr"/>
+          <a:lstStyle/>
+          <a:p>
+            <a:pPr algn="ctr"/>
+            <a:endParaRPr lang="en-IN"/>
+          </a:p>
+        </p:txBody>
+      </p:sp>
+      <p:sp>
+        <p:nvSpPr>
+          <p:cNvPr id="34" name="Freeform 33"/>
+          <p:cNvSpPr/>
+          <p:nvPr/>
+        </p:nvSpPr>
+        <p:spPr>
+          <a:xfrm>
+            <a:off x="3016665" y="1333144"/>
+            <a:ext cx="178356" cy="137685"/>
+          </a:xfrm>
+          <a:custGeom>
+            <a:avLst/>
+            <a:gdLst>
+              <a:gd name="connsiteX0" fmla="*/ 0 w 178356"/>
+              <a:gd name="connsiteY0" fmla="*/ 0 h 137685"/>
+              <a:gd name="connsiteX1" fmla="*/ 68367 w 178356"/>
+              <a:gd name="connsiteY1" fmla="*/ 136733 h 137685"/>
+              <a:gd name="connsiteX2" fmla="*/ 170916 w 178356"/>
+              <a:gd name="connsiteY2" fmla="*/ 59820 h 137685"/>
+              <a:gd name="connsiteX3" fmla="*/ 162371 w 178356"/>
+              <a:gd name="connsiteY3" fmla="*/ 42729 h 137685"/>
+            </a:gdLst>
+            <a:ahLst/>
+            <a:cxnLst>
+              <a:cxn ang="0">
+                <a:pos x="connsiteX0" y="connsiteY0"/>
+              </a:cxn>
+              <a:cxn ang="0">
+                <a:pos x="connsiteX1" y="connsiteY1"/>
+              </a:cxn>
+              <a:cxn ang="0">
+                <a:pos x="connsiteX2" y="connsiteY2"/>
+              </a:cxn>
+              <a:cxn ang="0">
+                <a:pos x="connsiteX3" y="connsiteY3"/>
+              </a:cxn>
+            </a:cxnLst>
+            <a:rect l="l" t="t" r="r" b="b"/>
+            <a:pathLst>
+              <a:path w="178356" h="137685">
+                <a:moveTo>
+                  <a:pt x="0" y="0"/>
+                </a:moveTo>
+                <a:cubicBezTo>
+                  <a:pt x="19940" y="63381"/>
+                  <a:pt x="39881" y="126763"/>
+                  <a:pt x="68367" y="136733"/>
+                </a:cubicBezTo>
+                <a:cubicBezTo>
+                  <a:pt x="96853" y="146703"/>
+                  <a:pt x="155249" y="75487"/>
+                  <a:pt x="170916" y="59820"/>
+                </a:cubicBezTo>
+                <a:cubicBezTo>
+                  <a:pt x="186583" y="44153"/>
+                  <a:pt x="174477" y="43441"/>
+                  <a:pt x="162371" y="42729"/>
+                </a:cubicBezTo>
+              </a:path>
+            </a:pathLst>
+          </a:custGeom>
+          <a:noFill/>
+          <a:ln w="57150"/>
+        </p:spPr>
+        <p:style>
+          <a:lnRef idx="2">
+            <a:schemeClr val="accent1">
+              <a:shade val="50000"/>
+            </a:schemeClr>
+          </a:lnRef>
+          <a:fillRef idx="1">
+            <a:schemeClr val="accent1"/>
+          </a:fillRef>
+          <a:effectRef idx="0">
+            <a:schemeClr val="accent1"/>
+          </a:effectRef>
+          <a:fontRef idx="minor">
+            <a:schemeClr val="lt1"/>
+          </a:fontRef>
+        </p:style>
+        <p:txBody>
+          <a:bodyPr rtlCol="0" anchor="ctr"/>
+          <a:lstStyle/>
+          <a:p>
+            <a:pPr algn="ctr"/>
+            <a:endParaRPr lang="en-IN"/>
+          </a:p>
+        </p:txBody>
+      </p:sp>
+      <p:sp>
+        <p:nvSpPr>
+          <p:cNvPr id="35" name="Right Arrow 34"/>
+          <p:cNvSpPr/>
+          <p:nvPr/>
+        </p:nvSpPr>
+        <p:spPr>
+          <a:xfrm rot="1666606">
+            <a:off x="3154054" y="1611238"/>
+            <a:ext cx="978408" cy="110384"/>
+          </a:xfrm>
+          <a:prstGeom prst="rightArrow">
+            <a:avLst/>
+          </a:prstGeom>
+        </p:spPr>
+        <p:style>
+          <a:lnRef idx="2">
+            <a:schemeClr val="accent1">
+              <a:shade val="50000"/>
+            </a:schemeClr>
+          </a:lnRef>
+          <a:fillRef idx="1">
+            <a:schemeClr val="accent1"/>
+          </a:fillRef>
+          <a:effectRef idx="0">
+            <a:schemeClr val="accent1"/>
+          </a:effectRef>
+          <a:fontRef idx="minor">
+            <a:schemeClr val="lt1"/>
+          </a:fontRef>
+        </p:style>
+        <p:txBody>
+          <a:bodyPr rtlCol="0" anchor="ctr"/>
+          <a:lstStyle/>
+          <a:p>
+            <a:pPr algn="ctr"/>
+            <a:endParaRPr lang="en-IN"/>
+          </a:p>
+        </p:txBody>
+      </p:sp>
+      <p:sp>
+        <p:nvSpPr>
+          <p:cNvPr id="37" name="TextBox 36"/>
+          <p:cNvSpPr txBox="1"/>
+          <p:nvPr/>
+        </p:nvSpPr>
+        <p:spPr>
+          <a:xfrm>
+            <a:off x="2820113" y="1895400"/>
+            <a:ext cx="1700616" cy="338554"/>
+          </a:xfrm>
+          <a:prstGeom prst="rect">
+            <a:avLst/>
+          </a:prstGeom>
+          <a:noFill/>
+        </p:spPr>
+        <p:txBody>
+          <a:bodyPr wrap="square" rtlCol="0">
+            <a:spAutoFit/>
+          </a:bodyPr>
+          <a:lstStyle/>
+          <a:p>
+            <a:r>
+              <a:rPr lang="ml-IN" sz="1600" b="1" i="1" dirty="0" smtClean="0">
+                <a:solidFill>
+                  <a:schemeClr val="bg1"/>
+                </a:solidFill>
+              </a:rPr>
+              <a:t>അസ്സോസ്</a:t>
+            </a:r>
+            <a:r>
+              <a:rPr lang="en-IN" sz="1600" b="1" i="1" dirty="0" smtClean="0">
+                <a:solidFill>
+                  <a:schemeClr val="bg1"/>
+                </a:solidFill>
+              </a:rPr>
+              <a:t>   </a:t>
+            </a:r>
+            <a:r>
+              <a:rPr lang="en-US" sz="1600" b="1" i="1" dirty="0" smtClean="0">
+                <a:solidFill>
+                  <a:schemeClr val="bg1"/>
+                </a:solidFill>
+              </a:rPr>
+              <a:t>.</a:t>
+            </a:r>
+            <a:r>
+              <a:rPr lang="ml-IN" sz="1600" b="1" i="1" dirty="0" smtClean="0">
+                <a:solidFill>
+                  <a:schemeClr val="bg1"/>
+                </a:solidFill>
+              </a:rPr>
+              <a:t> </a:t>
+            </a:r>
+            <a:endParaRPr lang="en-IN" sz="1600" b="1" i="1" dirty="0">
+              <a:solidFill>
+                <a:schemeClr val="bg1"/>
+              </a:solidFill>
+            </a:endParaRPr>
+          </a:p>
+        </p:txBody>
+      </p:sp>
+      <p:sp>
+        <p:nvSpPr>
+          <p:cNvPr id="38" name="Right Arrow 37"/>
+          <p:cNvSpPr/>
+          <p:nvPr/>
+        </p:nvSpPr>
+        <p:spPr>
+          <a:xfrm rot="3902790">
+            <a:off x="4039713" y="1920919"/>
+            <a:ext cx="200277" cy="133001"/>
+          </a:xfrm>
+          <a:prstGeom prst="rightArrow">
+            <a:avLst/>
+          </a:prstGeom>
+        </p:spPr>
+        <p:style>
+          <a:lnRef idx="2">
+            <a:schemeClr val="accent1">
+              <a:shade val="50000"/>
+            </a:schemeClr>
+          </a:lnRef>
+          <a:fillRef idx="1">
+            <a:schemeClr val="accent1"/>
+          </a:fillRef>
+          <a:effectRef idx="0">
+            <a:schemeClr val="accent1"/>
+          </a:effectRef>
+          <a:fontRef idx="minor">
+            <a:schemeClr val="lt1"/>
+          </a:fontRef>
+        </p:style>
+        <p:txBody>
+          <a:bodyPr rtlCol="0" anchor="ctr"/>
+          <a:lstStyle/>
+          <a:p>
+            <a:pPr algn="ctr"/>
+            <a:endParaRPr lang="en-IN"/>
+          </a:p>
+        </p:txBody>
+      </p:sp>
+      <p:sp>
+        <p:nvSpPr>
+          <p:cNvPr id="39" name="TextBox 38"/>
+          <p:cNvSpPr txBox="1"/>
+          <p:nvPr/>
+        </p:nvSpPr>
+        <p:spPr>
+          <a:xfrm>
+            <a:off x="3003680" y="2223546"/>
+            <a:ext cx="1700616" cy="338554"/>
+          </a:xfrm>
+          <a:prstGeom prst="rect">
+            <a:avLst/>
+          </a:prstGeom>
+          <a:noFill/>
+        </p:spPr>
+        <p:txBody>
+          <a:bodyPr wrap="square" rtlCol="0">
+            <a:spAutoFit/>
+          </a:bodyPr>
+          <a:lstStyle/>
+          <a:p>
+            <a:r>
+              <a:rPr lang="ml-IN" sz="1600" b="1" i="1" dirty="0">
+                <a:solidFill>
+                  <a:schemeClr val="bg1"/>
+                </a:solidFill>
+              </a:rPr>
+              <a:t>മിഥിലിനി</a:t>
+            </a:r>
+            <a:r>
+              <a:rPr lang="en-IN" sz="1600" b="1" i="1" dirty="0" smtClean="0">
+                <a:solidFill>
+                  <a:schemeClr val="bg1"/>
+                </a:solidFill>
+              </a:rPr>
+              <a:t>   </a:t>
+            </a:r>
+            <a:r>
+              <a:rPr lang="en-US" sz="1600" b="1" i="1" dirty="0" smtClean="0">
+                <a:solidFill>
+                  <a:schemeClr val="bg1"/>
+                </a:solidFill>
+              </a:rPr>
+              <a:t>.</a:t>
+            </a:r>
+            <a:r>
+              <a:rPr lang="ml-IN" sz="1600" b="1" i="1" dirty="0" smtClean="0">
+                <a:solidFill>
+                  <a:schemeClr val="bg1"/>
+                </a:solidFill>
+              </a:rPr>
+              <a:t> </a:t>
+            </a:r>
+            <a:endParaRPr lang="en-IN" sz="1600" b="1" i="1" dirty="0">
+              <a:solidFill>
+                <a:schemeClr val="bg1"/>
+              </a:solidFill>
+            </a:endParaRPr>
+          </a:p>
+        </p:txBody>
+      </p:sp>
+      <p:sp>
+        <p:nvSpPr>
+          <p:cNvPr id="40" name="Right Arrow 39"/>
+          <p:cNvSpPr/>
+          <p:nvPr/>
+        </p:nvSpPr>
+        <p:spPr>
+          <a:xfrm rot="3585837">
+            <a:off x="4116853" y="2191796"/>
+            <a:ext cx="270341" cy="142296"/>
+          </a:xfrm>
+          <a:prstGeom prst="rightArrow">
+            <a:avLst/>
+          </a:prstGeom>
+        </p:spPr>
+        <p:style>
+          <a:lnRef idx="2">
+            <a:schemeClr val="accent1">
+              <a:shade val="50000"/>
+            </a:schemeClr>
+          </a:lnRef>
+          <a:fillRef idx="1">
+            <a:schemeClr val="accent1"/>
+          </a:fillRef>
+          <a:effectRef idx="0">
+            <a:schemeClr val="accent1"/>
+          </a:effectRef>
+          <a:fontRef idx="minor">
+            <a:schemeClr val="lt1"/>
+          </a:fontRef>
+        </p:style>
+        <p:txBody>
+          <a:bodyPr rtlCol="0" anchor="ctr"/>
+          <a:lstStyle/>
+          <a:p>
+            <a:pPr algn="ctr"/>
+            <a:endParaRPr lang="en-IN"/>
+          </a:p>
+        </p:txBody>
+      </p:sp>
+      <p:sp>
+        <p:nvSpPr>
+          <p:cNvPr id="41" name="TextBox 40"/>
+          <p:cNvSpPr txBox="1"/>
+          <p:nvPr/>
+        </p:nvSpPr>
+        <p:spPr>
+          <a:xfrm rot="599865">
+            <a:off x="2982848" y="3113947"/>
+            <a:ext cx="1700616" cy="338554"/>
+          </a:xfrm>
+          <a:prstGeom prst="rect">
+            <a:avLst/>
+          </a:prstGeom>
+          <a:noFill/>
+        </p:spPr>
+        <p:txBody>
+          <a:bodyPr wrap="square" rtlCol="0">
+            <a:spAutoFit/>
+          </a:bodyPr>
+          <a:lstStyle/>
+          <a:p>
+            <a:r>
+              <a:rPr lang="ml-IN" sz="1600" b="1" dirty="0" smtClean="0">
+                <a:solidFill>
+                  <a:schemeClr val="bg1"/>
+                </a:solidFill>
+              </a:rPr>
+              <a:t>സാമോസ്</a:t>
+            </a:r>
+            <a:r>
+              <a:rPr lang="en-IN" sz="1600" b="1" dirty="0" smtClean="0">
+                <a:solidFill>
+                  <a:schemeClr val="bg1"/>
+                </a:solidFill>
+              </a:rPr>
+              <a:t>  </a:t>
+            </a:r>
+            <a:r>
+              <a:rPr lang="en-US" sz="1600" b="1" dirty="0" smtClean="0">
+                <a:solidFill>
+                  <a:schemeClr val="bg1"/>
+                </a:solidFill>
+              </a:rPr>
+              <a:t>.</a:t>
+            </a:r>
+            <a:r>
+              <a:rPr lang="ml-IN" sz="1600" b="1" dirty="0" smtClean="0">
+                <a:solidFill>
+                  <a:schemeClr val="bg1"/>
+                </a:solidFill>
+              </a:rPr>
+              <a:t> </a:t>
+            </a:r>
+            <a:endParaRPr lang="en-IN" sz="1600" b="1" dirty="0">
+              <a:solidFill>
+                <a:schemeClr val="bg1"/>
+              </a:solidFill>
+            </a:endParaRPr>
+          </a:p>
+        </p:txBody>
+      </p:sp>
+      <p:sp>
+        <p:nvSpPr>
+          <p:cNvPr id="42" name="Freeform 41"/>
+          <p:cNvSpPr/>
+          <p:nvPr/>
+        </p:nvSpPr>
+        <p:spPr>
+          <a:xfrm>
+            <a:off x="4050292" y="2521009"/>
+            <a:ext cx="256788" cy="799152"/>
+          </a:xfrm>
+          <a:custGeom>
+            <a:avLst/>
+            <a:gdLst>
+              <a:gd name="connsiteX0" fmla="*/ 256788 w 256788"/>
+              <a:gd name="connsiteY0" fmla="*/ 0 h 799152"/>
+              <a:gd name="connsiteX1" fmla="*/ 415 w 256788"/>
+              <a:gd name="connsiteY1" fmla="*/ 299103 h 799152"/>
+              <a:gd name="connsiteX2" fmla="*/ 196968 w 256788"/>
+              <a:gd name="connsiteY2" fmla="*/ 743484 h 799152"/>
+              <a:gd name="connsiteX3" fmla="*/ 205514 w 256788"/>
+              <a:gd name="connsiteY3" fmla="*/ 777668 h 799152"/>
+            </a:gdLst>
+            <a:ahLst/>
+            <a:cxnLst>
+              <a:cxn ang="0">
+                <a:pos x="connsiteX0" y="connsiteY0"/>
+              </a:cxn>
+              <a:cxn ang="0">
+                <a:pos x="connsiteX1" y="connsiteY1"/>
+              </a:cxn>
+              <a:cxn ang="0">
+                <a:pos x="connsiteX2" y="connsiteY2"/>
+              </a:cxn>
+              <a:cxn ang="0">
+                <a:pos x="connsiteX3" y="connsiteY3"/>
+              </a:cxn>
+            </a:cxnLst>
+            <a:rect l="l" t="t" r="r" b="b"/>
+            <a:pathLst>
+              <a:path w="256788" h="799152">
+                <a:moveTo>
+                  <a:pt x="256788" y="0"/>
+                </a:moveTo>
+                <a:cubicBezTo>
+                  <a:pt x="133586" y="87594"/>
+                  <a:pt x="10385" y="175189"/>
+                  <a:pt x="415" y="299103"/>
+                </a:cubicBezTo>
+                <a:cubicBezTo>
+                  <a:pt x="-9555" y="423017"/>
+                  <a:pt x="162785" y="663723"/>
+                  <a:pt x="196968" y="743484"/>
+                </a:cubicBezTo>
+                <a:cubicBezTo>
+                  <a:pt x="231151" y="823245"/>
+                  <a:pt x="218332" y="800456"/>
+                  <a:pt x="205514" y="777668"/>
+                </a:cubicBezTo>
+              </a:path>
+            </a:pathLst>
+          </a:custGeom>
+          <a:noFill/>
+          <a:ln w="76200"/>
+        </p:spPr>
+        <p:style>
+          <a:lnRef idx="2">
+            <a:schemeClr val="accent1">
+              <a:shade val="50000"/>
+            </a:schemeClr>
+          </a:lnRef>
+          <a:fillRef idx="1">
+            <a:schemeClr val="accent1"/>
+          </a:fillRef>
+          <a:effectRef idx="0">
+            <a:schemeClr val="accent1"/>
+          </a:effectRef>
+          <a:fontRef idx="minor">
+            <a:schemeClr val="lt1"/>
+          </a:fontRef>
+        </p:style>
+        <p:txBody>
+          <a:bodyPr rtlCol="0" anchor="ctr"/>
+          <a:lstStyle/>
+          <a:p>
+            <a:pPr algn="ctr"/>
+            <a:endParaRPr lang="en-IN"/>
+          </a:p>
+        </p:txBody>
+      </p:sp>
+      <p:sp>
+        <p:nvSpPr>
+          <p:cNvPr id="43" name="TextBox 42"/>
+          <p:cNvSpPr txBox="1"/>
+          <p:nvPr/>
+        </p:nvSpPr>
+        <p:spPr>
+          <a:xfrm rot="20486565">
+            <a:off x="3406134" y="3331021"/>
+            <a:ext cx="2227599" cy="338554"/>
+          </a:xfrm>
+          <a:prstGeom prst="rect">
+            <a:avLst/>
+          </a:prstGeom>
+          <a:noFill/>
+        </p:spPr>
+        <p:txBody>
+          <a:bodyPr wrap="square" rtlCol="0">
+            <a:spAutoFit/>
+          </a:bodyPr>
+          <a:lstStyle/>
+          <a:p>
+            <a:r>
+              <a:rPr lang="ml-IN" sz="1600" b="1" i="1" dirty="0">
+                <a:solidFill>
+                  <a:schemeClr val="bg1"/>
+                </a:solidFill>
+              </a:rPr>
+              <a:t>മിലീത്തോസ്</a:t>
+            </a:r>
+            <a:r>
+              <a:rPr lang="en-IN" sz="1600" b="1" i="1" dirty="0" smtClean="0">
+                <a:solidFill>
+                  <a:schemeClr val="bg1"/>
+                </a:solidFill>
+              </a:rPr>
+              <a:t>    </a:t>
+            </a:r>
+            <a:r>
+              <a:rPr lang="en-US" sz="1600" b="1" i="1" dirty="0" smtClean="0">
+                <a:solidFill>
+                  <a:schemeClr val="bg1"/>
+                </a:solidFill>
+              </a:rPr>
+              <a:t>.</a:t>
+            </a:r>
+            <a:r>
+              <a:rPr lang="ml-IN" sz="1600" b="1" i="1" dirty="0" smtClean="0">
+                <a:solidFill>
+                  <a:schemeClr val="bg1"/>
+                </a:solidFill>
+              </a:rPr>
+              <a:t> </a:t>
+            </a:r>
+            <a:endParaRPr lang="en-IN" sz="1600" b="1" i="1" dirty="0">
+              <a:solidFill>
+                <a:schemeClr val="bg1"/>
+              </a:solidFill>
+            </a:endParaRPr>
+          </a:p>
+        </p:txBody>
+      </p:sp>
+      <p:sp>
+        <p:nvSpPr>
+          <p:cNvPr id="44" name="Freeform 43"/>
+          <p:cNvSpPr/>
+          <p:nvPr/>
+        </p:nvSpPr>
+        <p:spPr>
+          <a:xfrm>
+            <a:off x="4366901" y="3179010"/>
+            <a:ext cx="683663" cy="119667"/>
+          </a:xfrm>
+          <a:custGeom>
+            <a:avLst/>
+            <a:gdLst>
+              <a:gd name="connsiteX0" fmla="*/ 0 w 683663"/>
+              <a:gd name="connsiteY0" fmla="*/ 111121 h 119667"/>
+              <a:gd name="connsiteX1" fmla="*/ 444381 w 683663"/>
+              <a:gd name="connsiteY1" fmla="*/ 26 h 119667"/>
+              <a:gd name="connsiteX2" fmla="*/ 683663 w 683663"/>
+              <a:gd name="connsiteY2" fmla="*/ 119667 h 119667"/>
+              <a:gd name="connsiteX3" fmla="*/ 683663 w 683663"/>
+              <a:gd name="connsiteY3" fmla="*/ 119667 h 119667"/>
+            </a:gdLst>
+            <a:ahLst/>
+            <a:cxnLst>
+              <a:cxn ang="0">
+                <a:pos x="connsiteX0" y="connsiteY0"/>
+              </a:cxn>
+              <a:cxn ang="0">
+                <a:pos x="connsiteX1" y="connsiteY1"/>
+              </a:cxn>
+              <a:cxn ang="0">
+                <a:pos x="connsiteX2" y="connsiteY2"/>
+              </a:cxn>
+              <a:cxn ang="0">
+                <a:pos x="connsiteX3" y="connsiteY3"/>
+              </a:cxn>
+            </a:cxnLst>
+            <a:rect l="l" t="t" r="r" b="b"/>
+            <a:pathLst>
+              <a:path w="683663" h="119667">
+                <a:moveTo>
+                  <a:pt x="0" y="111121"/>
+                </a:moveTo>
+                <a:cubicBezTo>
+                  <a:pt x="165218" y="54861"/>
+                  <a:pt x="330437" y="-1398"/>
+                  <a:pt x="444381" y="26"/>
+                </a:cubicBezTo>
+                <a:cubicBezTo>
+                  <a:pt x="558325" y="1450"/>
+                  <a:pt x="683663" y="119667"/>
+                  <a:pt x="683663" y="119667"/>
+                </a:cubicBezTo>
+                <a:lnTo>
+                  <a:pt x="683663" y="119667"/>
+                </a:lnTo>
+              </a:path>
+            </a:pathLst>
+          </a:custGeom>
+          <a:noFill/>
+          <a:ln w="76200"/>
+        </p:spPr>
+        <p:style>
+          <a:lnRef idx="2">
+            <a:schemeClr val="accent1">
+              <a:shade val="50000"/>
+            </a:schemeClr>
+          </a:lnRef>
+          <a:fillRef idx="1">
+            <a:schemeClr val="accent1"/>
+          </a:fillRef>
+          <a:effectRef idx="0">
+            <a:schemeClr val="accent1"/>
+          </a:effectRef>
+          <a:fontRef idx="minor">
+            <a:schemeClr val="lt1"/>
+          </a:fontRef>
+        </p:style>
+        <p:txBody>
+          <a:bodyPr rtlCol="0" anchor="ctr"/>
+          <a:lstStyle/>
+          <a:p>
+            <a:pPr algn="ctr"/>
+            <a:endParaRPr lang="en-IN"/>
+          </a:p>
+        </p:txBody>
+      </p:sp>
+      <p:sp>
+        <p:nvSpPr>
+          <p:cNvPr id="46" name="TextBox 45"/>
+          <p:cNvSpPr txBox="1"/>
+          <p:nvPr/>
+        </p:nvSpPr>
+        <p:spPr>
+          <a:xfrm rot="20486565">
+            <a:off x="3507897" y="3667187"/>
+            <a:ext cx="1560114" cy="338554"/>
+          </a:xfrm>
+          <a:prstGeom prst="rect">
+            <a:avLst/>
+          </a:prstGeom>
+          <a:noFill/>
+        </p:spPr>
+        <p:txBody>
+          <a:bodyPr wrap="square" rtlCol="0">
+            <a:spAutoFit/>
+          </a:bodyPr>
+          <a:lstStyle/>
+          <a:p>
+            <a:r>
+              <a:rPr lang="ml-IN" sz="1600" b="1" i="1" dirty="0" smtClean="0">
+                <a:solidFill>
+                  <a:schemeClr val="bg1"/>
+                </a:solidFill>
+              </a:rPr>
+              <a:t>കോസ്</a:t>
+            </a:r>
+            <a:r>
+              <a:rPr lang="en-IN" sz="1600" b="1" i="1" dirty="0" smtClean="0">
+                <a:solidFill>
+                  <a:schemeClr val="bg1"/>
+                </a:solidFill>
+              </a:rPr>
+              <a:t>    </a:t>
+            </a:r>
+            <a:r>
+              <a:rPr lang="en-US" sz="1600" b="1" i="1" dirty="0" smtClean="0">
+                <a:solidFill>
+                  <a:schemeClr val="bg1"/>
+                </a:solidFill>
+              </a:rPr>
+              <a:t>.</a:t>
+            </a:r>
+            <a:r>
+              <a:rPr lang="ml-IN" sz="1600" b="1" i="1" dirty="0" smtClean="0">
+                <a:solidFill>
+                  <a:schemeClr val="bg1"/>
+                </a:solidFill>
+              </a:rPr>
+              <a:t> </a:t>
+            </a:r>
+            <a:endParaRPr lang="en-IN" sz="1600" b="1" i="1" dirty="0">
+              <a:solidFill>
+                <a:schemeClr val="bg1"/>
+              </a:solidFill>
+            </a:endParaRPr>
+          </a:p>
+        </p:txBody>
+      </p:sp>
+      <p:sp>
+        <p:nvSpPr>
+          <p:cNvPr id="47" name="Freeform 46"/>
+          <p:cNvSpPr/>
+          <p:nvPr/>
+        </p:nvSpPr>
+        <p:spPr>
+          <a:xfrm>
+            <a:off x="4606183" y="3390272"/>
+            <a:ext cx="478565" cy="352786"/>
+          </a:xfrm>
+          <a:custGeom>
+            <a:avLst/>
+            <a:gdLst>
+              <a:gd name="connsiteX0" fmla="*/ 478565 w 478565"/>
+              <a:gd name="connsiteY0" fmla="*/ 19500 h 352786"/>
+              <a:gd name="connsiteX1" fmla="*/ 307649 w 478565"/>
+              <a:gd name="connsiteY1" fmla="*/ 36592 h 352786"/>
+              <a:gd name="connsiteX2" fmla="*/ 0 w 478565"/>
+              <a:gd name="connsiteY2" fmla="*/ 352786 h 352786"/>
+              <a:gd name="connsiteX3" fmla="*/ 0 w 478565"/>
+              <a:gd name="connsiteY3" fmla="*/ 352786 h 352786"/>
+            </a:gdLst>
+            <a:ahLst/>
+            <a:cxnLst>
+              <a:cxn ang="0">
+                <a:pos x="connsiteX0" y="connsiteY0"/>
+              </a:cxn>
+              <a:cxn ang="0">
+                <a:pos x="connsiteX1" y="connsiteY1"/>
+              </a:cxn>
+              <a:cxn ang="0">
+                <a:pos x="connsiteX2" y="connsiteY2"/>
+              </a:cxn>
+              <a:cxn ang="0">
+                <a:pos x="connsiteX3" y="connsiteY3"/>
+              </a:cxn>
+            </a:cxnLst>
+            <a:rect l="l" t="t" r="r" b="b"/>
+            <a:pathLst>
+              <a:path w="478565" h="352786">
+                <a:moveTo>
+                  <a:pt x="478565" y="19500"/>
+                </a:moveTo>
+                <a:cubicBezTo>
+                  <a:pt x="432987" y="272"/>
+                  <a:pt x="387410" y="-18956"/>
+                  <a:pt x="307649" y="36592"/>
+                </a:cubicBezTo>
+                <a:cubicBezTo>
+                  <a:pt x="227888" y="92140"/>
+                  <a:pt x="0" y="352786"/>
+                  <a:pt x="0" y="352786"/>
+                </a:cubicBezTo>
+                <a:lnTo>
+                  <a:pt x="0" y="352786"/>
+                </a:lnTo>
+              </a:path>
+            </a:pathLst>
+          </a:custGeom>
+          <a:noFill/>
+          <a:ln w="76200"/>
+        </p:spPr>
+        <p:style>
+          <a:lnRef idx="2">
+            <a:schemeClr val="accent1">
+              <a:shade val="50000"/>
+            </a:schemeClr>
+          </a:lnRef>
+          <a:fillRef idx="1">
+            <a:schemeClr val="accent1"/>
+          </a:fillRef>
+          <a:effectRef idx="0">
+            <a:schemeClr val="accent1"/>
+          </a:effectRef>
+          <a:fontRef idx="minor">
+            <a:schemeClr val="lt1"/>
+          </a:fontRef>
+        </p:style>
+        <p:txBody>
+          <a:bodyPr rtlCol="0" anchor="ctr"/>
+          <a:lstStyle/>
+          <a:p>
+            <a:pPr algn="ctr"/>
+            <a:endParaRPr lang="en-IN"/>
+          </a:p>
+        </p:txBody>
+      </p:sp>
+      <p:sp>
+        <p:nvSpPr>
+          <p:cNvPr id="48" name="TextBox 47"/>
+          <p:cNvSpPr txBox="1"/>
+          <p:nvPr/>
+        </p:nvSpPr>
+        <p:spPr>
+          <a:xfrm rot="1062486">
+            <a:off x="6850523" y="3676226"/>
+            <a:ext cx="1323450" cy="338554"/>
+          </a:xfrm>
+          <a:prstGeom prst="rect">
+            <a:avLst/>
+          </a:prstGeom>
+          <a:noFill/>
+        </p:spPr>
+        <p:txBody>
+          <a:bodyPr wrap="square" rtlCol="0">
+            <a:spAutoFit/>
+          </a:bodyPr>
+          <a:lstStyle/>
+          <a:p>
+            <a:r>
+              <a:rPr lang="en-US" sz="1600" b="1" i="1" dirty="0" smtClean="0">
+                <a:solidFill>
+                  <a:schemeClr val="bg1"/>
+                </a:solidFill>
+              </a:rPr>
+              <a:t>. </a:t>
+            </a:r>
+            <a:r>
+              <a:rPr lang="ml-IN" sz="1600" b="1" i="1" dirty="0">
+                <a:solidFill>
+                  <a:schemeClr val="bg1"/>
+                </a:solidFill>
+              </a:rPr>
+              <a:t>പത്തര</a:t>
+            </a:r>
+            <a:r>
+              <a:rPr lang="ml-IN" sz="1600" b="1" i="1" dirty="0" smtClean="0">
+                <a:solidFill>
+                  <a:schemeClr val="bg1"/>
+                </a:solidFill>
+              </a:rPr>
+              <a:t> </a:t>
+            </a:r>
+            <a:endParaRPr lang="en-IN" sz="1600" b="1" i="1" dirty="0">
+              <a:solidFill>
+                <a:schemeClr val="bg1"/>
+              </a:solidFill>
+            </a:endParaRPr>
+          </a:p>
+        </p:txBody>
+      </p:sp>
+      <p:sp>
+        <p:nvSpPr>
+          <p:cNvPr id="49" name="Freeform 48"/>
+          <p:cNvSpPr/>
+          <p:nvPr/>
+        </p:nvSpPr>
+        <p:spPr>
+          <a:xfrm>
+            <a:off x="4648912" y="3695066"/>
+            <a:ext cx="2494962" cy="556807"/>
+          </a:xfrm>
+          <a:custGeom>
+            <a:avLst/>
+            <a:gdLst>
+              <a:gd name="connsiteX0" fmla="*/ 0 w 2494962"/>
+              <a:gd name="connsiteY0" fmla="*/ 124904 h 556807"/>
+              <a:gd name="connsiteX1" fmla="*/ 418744 w 2494962"/>
+              <a:gd name="connsiteY1" fmla="*/ 193270 h 556807"/>
+              <a:gd name="connsiteX2" fmla="*/ 820396 w 2494962"/>
+              <a:gd name="connsiteY2" fmla="*/ 107813 h 556807"/>
+              <a:gd name="connsiteX3" fmla="*/ 1888621 w 2494962"/>
+              <a:gd name="connsiteY3" fmla="*/ 552194 h 556807"/>
+              <a:gd name="connsiteX4" fmla="*/ 2478281 w 2494962"/>
+              <a:gd name="connsiteY4" fmla="*/ 321457 h 556807"/>
+              <a:gd name="connsiteX5" fmla="*/ 2333002 w 2494962"/>
+              <a:gd name="connsiteY5" fmla="*/ 30900 h 556807"/>
+              <a:gd name="connsiteX6" fmla="*/ 2333002 w 2494962"/>
+              <a:gd name="connsiteY6" fmla="*/ 22355 h 556807"/>
+            </a:gdLst>
+            <a:ahLst/>
+            <a:cxnLst>
+              <a:cxn ang="0">
+                <a:pos x="connsiteX0" y="connsiteY0"/>
+              </a:cxn>
+              <a:cxn ang="0">
+                <a:pos x="connsiteX1" y="connsiteY1"/>
+              </a:cxn>
+              <a:cxn ang="0">
+                <a:pos x="connsiteX2" y="connsiteY2"/>
+              </a:cxn>
+              <a:cxn ang="0">
+                <a:pos x="connsiteX3" y="connsiteY3"/>
+              </a:cxn>
+              <a:cxn ang="0">
+                <a:pos x="connsiteX4" y="connsiteY4"/>
+              </a:cxn>
+              <a:cxn ang="0">
+                <a:pos x="connsiteX5" y="connsiteY5"/>
+              </a:cxn>
+              <a:cxn ang="0">
+                <a:pos x="connsiteX6" y="connsiteY6"/>
+              </a:cxn>
+            </a:cxnLst>
+            <a:rect l="l" t="t" r="r" b="b"/>
+            <a:pathLst>
+              <a:path w="2494962" h="556807">
+                <a:moveTo>
+                  <a:pt x="0" y="124904"/>
+                </a:moveTo>
+                <a:cubicBezTo>
+                  <a:pt x="141005" y="160511"/>
+                  <a:pt x="282011" y="196119"/>
+                  <a:pt x="418744" y="193270"/>
+                </a:cubicBezTo>
+                <a:cubicBezTo>
+                  <a:pt x="555477" y="190422"/>
+                  <a:pt x="575417" y="47992"/>
+                  <a:pt x="820396" y="107813"/>
+                </a:cubicBezTo>
+                <a:cubicBezTo>
+                  <a:pt x="1065375" y="167634"/>
+                  <a:pt x="1612307" y="516587"/>
+                  <a:pt x="1888621" y="552194"/>
+                </a:cubicBezTo>
+                <a:cubicBezTo>
+                  <a:pt x="2164935" y="587801"/>
+                  <a:pt x="2404218" y="408339"/>
+                  <a:pt x="2478281" y="321457"/>
+                </a:cubicBezTo>
+                <a:cubicBezTo>
+                  <a:pt x="2552344" y="234575"/>
+                  <a:pt x="2357215" y="80750"/>
+                  <a:pt x="2333002" y="30900"/>
+                </a:cubicBezTo>
+                <a:cubicBezTo>
+                  <a:pt x="2308789" y="-18950"/>
+                  <a:pt x="2320895" y="1702"/>
+                  <a:pt x="2333002" y="22355"/>
+                </a:cubicBezTo>
+              </a:path>
+            </a:pathLst>
+          </a:custGeom>
+          <a:noFill/>
+          <a:ln w="76200"/>
+        </p:spPr>
+        <p:style>
+          <a:lnRef idx="2">
+            <a:schemeClr val="accent1">
+              <a:shade val="50000"/>
+            </a:schemeClr>
+          </a:lnRef>
+          <a:fillRef idx="1">
+            <a:schemeClr val="accent1"/>
+          </a:fillRef>
+          <a:effectRef idx="0">
+            <a:schemeClr val="accent1"/>
+          </a:effectRef>
+          <a:fontRef idx="minor">
+            <a:schemeClr val="lt1"/>
+          </a:fontRef>
+        </p:style>
+        <p:txBody>
+          <a:bodyPr rtlCol="0" anchor="ctr"/>
+          <a:lstStyle/>
+          <a:p>
+            <a:pPr algn="ctr"/>
+            <a:endParaRPr lang="en-IN"/>
+          </a:p>
+        </p:txBody>
+      </p:sp>
+      <p:sp>
+        <p:nvSpPr>
+          <p:cNvPr id="50" name="Freeform 49"/>
+          <p:cNvSpPr/>
+          <p:nvPr/>
+        </p:nvSpPr>
+        <p:spPr>
+          <a:xfrm>
+            <a:off x="7204105" y="3845607"/>
+            <a:ext cx="2763507" cy="1487770"/>
+          </a:xfrm>
+          <a:custGeom>
+            <a:avLst/>
+            <a:gdLst>
+              <a:gd name="connsiteX0" fmla="*/ 0 w 2763507"/>
+              <a:gd name="connsiteY0" fmla="*/ 0 h 1487770"/>
+              <a:gd name="connsiteX1" fmla="*/ 572568 w 2763507"/>
+              <a:gd name="connsiteY1" fmla="*/ 1153683 h 1487770"/>
+              <a:gd name="connsiteX2" fmla="*/ 2555192 w 2763507"/>
+              <a:gd name="connsiteY2" fmla="*/ 1452786 h 1487770"/>
+              <a:gd name="connsiteX3" fmla="*/ 2606467 w 2763507"/>
+              <a:gd name="connsiteY3" fmla="*/ 1469877 h 1487770"/>
+            </a:gdLst>
+            <a:ahLst/>
+            <a:cxnLst>
+              <a:cxn ang="0">
+                <a:pos x="connsiteX0" y="connsiteY0"/>
+              </a:cxn>
+              <a:cxn ang="0">
+                <a:pos x="connsiteX1" y="connsiteY1"/>
+              </a:cxn>
+              <a:cxn ang="0">
+                <a:pos x="connsiteX2" y="connsiteY2"/>
+              </a:cxn>
+              <a:cxn ang="0">
+                <a:pos x="connsiteX3" y="connsiteY3"/>
+              </a:cxn>
+            </a:cxnLst>
+            <a:rect l="l" t="t" r="r" b="b"/>
+            <a:pathLst>
+              <a:path w="2763507" h="1487770">
+                <a:moveTo>
+                  <a:pt x="0" y="0"/>
+                </a:moveTo>
+                <a:cubicBezTo>
+                  <a:pt x="73351" y="455776"/>
+                  <a:pt x="146703" y="911552"/>
+                  <a:pt x="572568" y="1153683"/>
+                </a:cubicBezTo>
+                <a:cubicBezTo>
+                  <a:pt x="998433" y="1395814"/>
+                  <a:pt x="2216209" y="1400087"/>
+                  <a:pt x="2555192" y="1452786"/>
+                </a:cubicBezTo>
+                <a:cubicBezTo>
+                  <a:pt x="2894175" y="1505485"/>
+                  <a:pt x="2750321" y="1487681"/>
+                  <a:pt x="2606467" y="1469877"/>
+                </a:cubicBezTo>
+              </a:path>
+            </a:pathLst>
+          </a:custGeom>
+          <a:noFill/>
+          <a:ln w="76200"/>
+        </p:spPr>
+        <p:style>
+          <a:lnRef idx="2">
+            <a:schemeClr val="accent1">
+              <a:shade val="50000"/>
+            </a:schemeClr>
+          </a:lnRef>
+          <a:fillRef idx="1">
+            <a:schemeClr val="accent1"/>
+          </a:fillRef>
+          <a:effectRef idx="0">
+            <a:schemeClr val="accent1"/>
+          </a:effectRef>
+          <a:fontRef idx="minor">
+            <a:schemeClr val="lt1"/>
+          </a:fontRef>
+        </p:style>
+        <p:txBody>
+          <a:bodyPr rtlCol="0" anchor="ctr"/>
+          <a:lstStyle/>
+          <a:p>
+            <a:pPr algn="ctr"/>
+            <a:endParaRPr lang="en-IN"/>
+          </a:p>
+        </p:txBody>
+      </p:sp>
+      <p:sp>
+        <p:nvSpPr>
+          <p:cNvPr id="51" name="TextBox 50"/>
+          <p:cNvSpPr txBox="1"/>
+          <p:nvPr/>
+        </p:nvSpPr>
+        <p:spPr>
+          <a:xfrm>
+            <a:off x="9739660" y="5272272"/>
+            <a:ext cx="2418155" cy="338554"/>
+          </a:xfrm>
+          <a:prstGeom prst="rect">
+            <a:avLst/>
+          </a:prstGeom>
+          <a:noFill/>
+        </p:spPr>
+        <p:txBody>
+          <a:bodyPr wrap="square" rtlCol="0">
+            <a:spAutoFit/>
+          </a:bodyPr>
+          <a:lstStyle/>
+          <a:p>
+            <a:r>
+              <a:rPr lang="en-US" sz="1600" b="1" dirty="0" smtClean="0">
+                <a:solidFill>
+                  <a:schemeClr val="bg1"/>
+                </a:solidFill>
+              </a:rPr>
+              <a:t>.</a:t>
+            </a:r>
+            <a:r>
+              <a:rPr lang="ml-IN" sz="1600" b="1" dirty="0">
+                <a:solidFill>
+                  <a:schemeClr val="bg1"/>
+                </a:solidFill>
+              </a:rPr>
+              <a:t> പ്തൊലെമായിസ്</a:t>
+            </a:r>
+            <a:r>
+              <a:rPr lang="ml-IN" sz="1600" b="1" dirty="0" smtClean="0">
+                <a:solidFill>
+                  <a:schemeClr val="bg1"/>
+                </a:solidFill>
+              </a:rPr>
+              <a:t> </a:t>
+            </a:r>
+            <a:endParaRPr lang="en-IN" sz="1600" b="1" dirty="0">
+              <a:solidFill>
+                <a:schemeClr val="bg1"/>
+              </a:solidFill>
+            </a:endParaRPr>
+          </a:p>
+        </p:txBody>
+      </p:sp>
+      <p:sp>
+        <p:nvSpPr>
+          <p:cNvPr id="52" name="Down Arrow 51"/>
+          <p:cNvSpPr/>
+          <p:nvPr/>
+        </p:nvSpPr>
+        <p:spPr>
+          <a:xfrm>
+            <a:off x="9768570" y="5320159"/>
+            <a:ext cx="199042" cy="145124"/>
+          </a:xfrm>
+          <a:prstGeom prst="downArrow">
+            <a:avLst/>
+          </a:prstGeom>
+        </p:spPr>
+        <p:style>
+          <a:lnRef idx="2">
+            <a:schemeClr val="accent1">
+              <a:shade val="50000"/>
+            </a:schemeClr>
+          </a:lnRef>
+          <a:fillRef idx="1">
+            <a:schemeClr val="accent1"/>
+          </a:fillRef>
+          <a:effectRef idx="0">
+            <a:schemeClr val="accent1"/>
+          </a:effectRef>
+          <a:fontRef idx="minor">
+            <a:schemeClr val="lt1"/>
+          </a:fontRef>
+        </p:style>
+        <p:txBody>
+          <a:bodyPr rtlCol="0" anchor="ctr"/>
+          <a:lstStyle/>
+          <a:p>
+            <a:pPr algn="ctr"/>
+            <a:endParaRPr lang="en-IN"/>
+          </a:p>
+        </p:txBody>
+      </p:sp>
+      <p:sp>
+        <p:nvSpPr>
+          <p:cNvPr id="53" name="Down Arrow 52"/>
+          <p:cNvSpPr/>
+          <p:nvPr/>
+        </p:nvSpPr>
+        <p:spPr>
+          <a:xfrm>
+            <a:off x="9705475" y="5453350"/>
+            <a:ext cx="199042" cy="145124"/>
+          </a:xfrm>
+          <a:prstGeom prst="downArrow">
+            <a:avLst/>
+          </a:prstGeom>
+        </p:spPr>
+        <p:style>
+          <a:lnRef idx="2">
+            <a:schemeClr val="accent1">
+              <a:shade val="50000"/>
+            </a:schemeClr>
+          </a:lnRef>
+          <a:fillRef idx="1">
+            <a:schemeClr val="accent1"/>
+          </a:fillRef>
+          <a:effectRef idx="0">
+            <a:schemeClr val="accent1"/>
+          </a:effectRef>
+          <a:fontRef idx="minor">
+            <a:schemeClr val="lt1"/>
+          </a:fontRef>
+        </p:style>
+        <p:txBody>
+          <a:bodyPr rtlCol="0" anchor="ctr"/>
+          <a:lstStyle/>
+          <a:p>
+            <a:pPr algn="ctr"/>
+            <a:endParaRPr lang="en-IN"/>
+          </a:p>
+        </p:txBody>
+      </p:sp>
+      <p:sp>
+        <p:nvSpPr>
+          <p:cNvPr id="54" name="Right Arrow 53"/>
+          <p:cNvSpPr/>
+          <p:nvPr/>
+        </p:nvSpPr>
+        <p:spPr>
+          <a:xfrm rot="2156637">
+            <a:off x="9824760" y="5630555"/>
+            <a:ext cx="334300" cy="175782"/>
+          </a:xfrm>
+          <a:prstGeom prst="rightArrow">
+            <a:avLst/>
+          </a:prstGeom>
+        </p:spPr>
+        <p:style>
+          <a:lnRef idx="2">
+            <a:schemeClr val="accent1">
+              <a:shade val="50000"/>
+            </a:schemeClr>
+          </a:lnRef>
+          <a:fillRef idx="1">
+            <a:schemeClr val="accent1"/>
+          </a:fillRef>
+          <a:effectRef idx="0">
+            <a:schemeClr val="accent1"/>
+          </a:effectRef>
+          <a:fontRef idx="minor">
+            <a:schemeClr val="lt1"/>
+          </a:fontRef>
+        </p:style>
+        <p:txBody>
+          <a:bodyPr rtlCol="0" anchor="ctr"/>
+          <a:lstStyle/>
+          <a:p>
+            <a:pPr algn="ctr"/>
+            <a:endParaRPr lang="en-IN"/>
+          </a:p>
+        </p:txBody>
+      </p:sp>
+      <p:sp>
+        <p:nvSpPr>
+          <p:cNvPr id="55" name="Right Arrow 54"/>
+          <p:cNvSpPr/>
+          <p:nvPr/>
+        </p:nvSpPr>
+        <p:spPr>
+          <a:xfrm rot="1484747">
+            <a:off x="5906107" y="4029206"/>
+            <a:ext cx="410198" cy="136398"/>
+          </a:xfrm>
+          <a:prstGeom prst="rightArrow">
+            <a:avLst/>
+          </a:prstGeom>
+        </p:spPr>
+        <p:style>
+          <a:lnRef idx="2">
+            <a:schemeClr val="accent1">
+              <a:shade val="50000"/>
+            </a:schemeClr>
+          </a:lnRef>
+          <a:fillRef idx="1">
+            <a:schemeClr val="accent1"/>
+          </a:fillRef>
+          <a:effectRef idx="0">
+            <a:schemeClr val="accent1"/>
+          </a:effectRef>
+          <a:fontRef idx="minor">
+            <a:schemeClr val="lt1"/>
+          </a:fontRef>
+        </p:style>
+        <p:txBody>
+          <a:bodyPr rtlCol="0" anchor="ctr"/>
+          <a:lstStyle/>
+          <a:p>
+            <a:pPr algn="ctr"/>
+            <a:endParaRPr lang="en-IN"/>
+          </a:p>
+        </p:txBody>
+      </p:sp>
+      <p:sp>
+        <p:nvSpPr>
+          <p:cNvPr id="56" name="Right Arrow 55"/>
+          <p:cNvSpPr/>
+          <p:nvPr/>
+        </p:nvSpPr>
+        <p:spPr>
+          <a:xfrm rot="1484747">
+            <a:off x="7694900" y="4985443"/>
+            <a:ext cx="410198" cy="136398"/>
+          </a:xfrm>
+          <a:prstGeom prst="rightArrow">
+            <a:avLst/>
+          </a:prstGeom>
+        </p:spPr>
+        <p:style>
+          <a:lnRef idx="2">
+            <a:schemeClr val="accent1">
+              <a:shade val="50000"/>
+            </a:schemeClr>
+          </a:lnRef>
+          <a:fillRef idx="1">
+            <a:schemeClr val="accent1"/>
+          </a:fillRef>
+          <a:effectRef idx="0">
+            <a:schemeClr val="accent1"/>
+          </a:effectRef>
+          <a:fontRef idx="minor">
+            <a:schemeClr val="lt1"/>
+          </a:fontRef>
+        </p:style>
+        <p:txBody>
+          <a:bodyPr rtlCol="0" anchor="ctr"/>
+          <a:lstStyle/>
+          <a:p>
+            <a:pPr algn="ctr"/>
+            <a:endParaRPr lang="en-IN"/>
+          </a:p>
+        </p:txBody>
+      </p:sp>
+      <p:sp>
+        <p:nvSpPr>
+          <p:cNvPr id="57" name="Down Arrow 56"/>
+          <p:cNvSpPr/>
+          <p:nvPr/>
+        </p:nvSpPr>
+        <p:spPr>
+          <a:xfrm rot="20159708">
+            <a:off x="4071330" y="2958009"/>
+            <a:ext cx="161048" cy="201484"/>
+          </a:xfrm>
+          <a:prstGeom prst="downArrow">
+            <a:avLst/>
+          </a:prstGeom>
+        </p:spPr>
+        <p:style>
+          <a:lnRef idx="2">
+            <a:schemeClr val="accent1">
+              <a:shade val="50000"/>
+            </a:schemeClr>
+          </a:lnRef>
+          <a:fillRef idx="1">
+            <a:schemeClr val="accent1"/>
+          </a:fillRef>
+          <a:effectRef idx="0">
+            <a:schemeClr val="accent1"/>
+          </a:effectRef>
+          <a:fontRef idx="minor">
+            <a:schemeClr val="lt1"/>
+          </a:fontRef>
+        </p:style>
+        <p:txBody>
+          <a:bodyPr rtlCol="0" anchor="ctr"/>
+          <a:lstStyle/>
+          <a:p>
+            <a:pPr algn="ctr"/>
+            <a:endParaRPr lang="en-IN"/>
+          </a:p>
+        </p:txBody>
+      </p:sp>
+      <p:sp>
+        <p:nvSpPr>
+          <p:cNvPr id="58" name="Right Arrow 57"/>
+          <p:cNvSpPr/>
+          <p:nvPr/>
+        </p:nvSpPr>
+        <p:spPr>
+          <a:xfrm>
+            <a:off x="4657601" y="3116118"/>
+            <a:ext cx="209875" cy="164725"/>
+          </a:xfrm>
+          <a:prstGeom prst="rightArrow">
+            <a:avLst/>
+          </a:prstGeom>
+        </p:spPr>
+        <p:style>
+          <a:lnRef idx="2">
+            <a:schemeClr val="accent1">
+              <a:shade val="50000"/>
+            </a:schemeClr>
+          </a:lnRef>
+          <a:fillRef idx="1">
+            <a:schemeClr val="accent1"/>
+          </a:fillRef>
+          <a:effectRef idx="0">
+            <a:schemeClr val="accent1"/>
+          </a:effectRef>
+          <a:fontRef idx="minor">
+            <a:schemeClr val="lt1"/>
+          </a:fontRef>
+        </p:style>
+        <p:txBody>
+          <a:bodyPr rtlCol="0" anchor="ctr"/>
+          <a:lstStyle/>
+          <a:p>
+            <a:pPr algn="ctr"/>
+            <a:endParaRPr lang="en-IN"/>
+          </a:p>
+        </p:txBody>
+      </p:sp>
+      <p:sp>
+        <p:nvSpPr>
+          <p:cNvPr id="59" name="Down Arrow 58"/>
+          <p:cNvSpPr/>
+          <p:nvPr/>
+        </p:nvSpPr>
+        <p:spPr>
+          <a:xfrm rot="2145956">
+            <a:off x="4691692" y="3430327"/>
+            <a:ext cx="141692" cy="301630"/>
+          </a:xfrm>
+          <a:prstGeom prst="downArrow">
+            <a:avLst/>
+          </a:prstGeom>
         </p:spPr>
         <p:style>
           <a:lnRef idx="2">
@@ -7277,6 +9383,2334 @@
                       </p:childTnLst>
                     </p:cTn>
                   </p:par>
+                  <p:par>
+                    <p:cTn id="38" fill="hold">
+                      <p:stCondLst>
+                        <p:cond delay="indefinite"/>
+                      </p:stCondLst>
+                      <p:childTnLst>
+                        <p:par>
+                          <p:cTn id="39" fill="hold">
+                            <p:stCondLst>
+                              <p:cond delay="0"/>
+                            </p:stCondLst>
+                            <p:childTnLst>
+                              <p:par>
+                                <p:cTn id="40" presetID="1" presetClass="entr" presetSubtype="0" fill="hold" nodeType="clickEffect">
+                                  <p:stCondLst>
+                                    <p:cond delay="0"/>
+                                  </p:stCondLst>
+                                  <p:childTnLst>
+                                    <p:set>
+                                      <p:cBhvr>
+                                        <p:cTn id="41" dur="1" fill="hold">
+                                          <p:stCondLst>
+                                            <p:cond delay="0"/>
+                                          </p:stCondLst>
+                                        </p:cTn>
+                                        <p:tgtEl>
+                                          <p:spTgt spid="16"/>
+                                        </p:tgtEl>
+                                        <p:attrNameLst>
+                                          <p:attrName>style.visibility</p:attrName>
+                                        </p:attrNameLst>
+                                      </p:cBhvr>
+                                      <p:to>
+                                        <p:strVal val="visible"/>
+                                      </p:to>
+                                    </p:set>
+                                  </p:childTnLst>
+                                </p:cTn>
+                              </p:par>
+                            </p:childTnLst>
+                          </p:cTn>
+                        </p:par>
+                      </p:childTnLst>
+                    </p:cTn>
+                  </p:par>
+                  <p:par>
+                    <p:cTn id="42" fill="hold">
+                      <p:stCondLst>
+                        <p:cond delay="indefinite"/>
+                      </p:stCondLst>
+                      <p:childTnLst>
+                        <p:par>
+                          <p:cTn id="43" fill="hold">
+                            <p:stCondLst>
+                              <p:cond delay="0"/>
+                            </p:stCondLst>
+                            <p:childTnLst>
+                              <p:par>
+                                <p:cTn id="44" presetID="42" presetClass="entr" presetSubtype="0" fill="hold" grpId="0" nodeType="clickEffect">
+                                  <p:stCondLst>
+                                    <p:cond delay="0"/>
+                                  </p:stCondLst>
+                                  <p:childTnLst>
+                                    <p:set>
+                                      <p:cBhvr>
+                                        <p:cTn id="45" dur="1" fill="hold">
+                                          <p:stCondLst>
+                                            <p:cond delay="0"/>
+                                          </p:stCondLst>
+                                        </p:cTn>
+                                        <p:tgtEl>
+                                          <p:spTgt spid="18"/>
+                                        </p:tgtEl>
+                                        <p:attrNameLst>
+                                          <p:attrName>style.visibility</p:attrName>
+                                        </p:attrNameLst>
+                                      </p:cBhvr>
+                                      <p:to>
+                                        <p:strVal val="visible"/>
+                                      </p:to>
+                                    </p:set>
+                                    <p:animEffect transition="in" filter="fade">
+                                      <p:cBhvr>
+                                        <p:cTn id="46" dur="1000"/>
+                                        <p:tgtEl>
+                                          <p:spTgt spid="18"/>
+                                        </p:tgtEl>
+                                      </p:cBhvr>
+                                    </p:animEffect>
+                                    <p:anim calcmode="lin" valueType="num">
+                                      <p:cBhvr>
+                                        <p:cTn id="47" dur="1000" fill="hold"/>
+                                        <p:tgtEl>
+                                          <p:spTgt spid="18"/>
+                                        </p:tgtEl>
+                                        <p:attrNameLst>
+                                          <p:attrName>ppt_x</p:attrName>
+                                        </p:attrNameLst>
+                                      </p:cBhvr>
+                                      <p:tavLst>
+                                        <p:tav tm="0">
+                                          <p:val>
+                                            <p:strVal val="#ppt_x"/>
+                                          </p:val>
+                                        </p:tav>
+                                        <p:tav tm="100000">
+                                          <p:val>
+                                            <p:strVal val="#ppt_x"/>
+                                          </p:val>
+                                        </p:tav>
+                                      </p:tavLst>
+                                    </p:anim>
+                                    <p:anim calcmode="lin" valueType="num">
+                                      <p:cBhvr>
+                                        <p:cTn id="48" dur="1000" fill="hold"/>
+                                        <p:tgtEl>
+                                          <p:spTgt spid="18"/>
+                                        </p:tgtEl>
+                                        <p:attrNameLst>
+                                          <p:attrName>ppt_y</p:attrName>
+                                        </p:attrNameLst>
+                                      </p:cBhvr>
+                                      <p:tavLst>
+                                        <p:tav tm="0">
+                                          <p:val>
+                                            <p:strVal val="#ppt_y+.1"/>
+                                          </p:val>
+                                        </p:tav>
+                                        <p:tav tm="100000">
+                                          <p:val>
+                                            <p:strVal val="#ppt_y"/>
+                                          </p:val>
+                                        </p:tav>
+                                      </p:tavLst>
+                                    </p:anim>
+                                  </p:childTnLst>
+                                </p:cTn>
+                              </p:par>
+                            </p:childTnLst>
+                          </p:cTn>
+                        </p:par>
+                      </p:childTnLst>
+                    </p:cTn>
+                  </p:par>
+                  <p:par>
+                    <p:cTn id="49" fill="hold">
+                      <p:stCondLst>
+                        <p:cond delay="indefinite"/>
+                      </p:stCondLst>
+                      <p:childTnLst>
+                        <p:par>
+                          <p:cTn id="50" fill="hold">
+                            <p:stCondLst>
+                              <p:cond delay="0"/>
+                            </p:stCondLst>
+                            <p:childTnLst>
+                              <p:par>
+                                <p:cTn id="51" presetID="1" presetClass="entr" presetSubtype="0" fill="hold" nodeType="clickEffect">
+                                  <p:stCondLst>
+                                    <p:cond delay="0"/>
+                                  </p:stCondLst>
+                                  <p:childTnLst>
+                                    <p:set>
+                                      <p:cBhvr>
+                                        <p:cTn id="52" dur="1" fill="hold">
+                                          <p:stCondLst>
+                                            <p:cond delay="0"/>
+                                          </p:stCondLst>
+                                        </p:cTn>
+                                        <p:tgtEl>
+                                          <p:spTgt spid="19"/>
+                                        </p:tgtEl>
+                                        <p:attrNameLst>
+                                          <p:attrName>style.visibility</p:attrName>
+                                        </p:attrNameLst>
+                                      </p:cBhvr>
+                                      <p:to>
+                                        <p:strVal val="visible"/>
+                                      </p:to>
+                                    </p:set>
+                                  </p:childTnLst>
+                                </p:cTn>
+                              </p:par>
+                            </p:childTnLst>
+                          </p:cTn>
+                        </p:par>
+                      </p:childTnLst>
+                    </p:cTn>
+                  </p:par>
+                  <p:par>
+                    <p:cTn id="53" fill="hold">
+                      <p:stCondLst>
+                        <p:cond delay="indefinite"/>
+                      </p:stCondLst>
+                      <p:childTnLst>
+                        <p:par>
+                          <p:cTn id="54" fill="hold">
+                            <p:stCondLst>
+                              <p:cond delay="0"/>
+                            </p:stCondLst>
+                            <p:childTnLst>
+                              <p:par>
+                                <p:cTn id="55" presetID="42" presetClass="entr" presetSubtype="0" fill="hold" grpId="0" nodeType="clickEffect">
+                                  <p:stCondLst>
+                                    <p:cond delay="0"/>
+                                  </p:stCondLst>
+                                  <p:childTnLst>
+                                    <p:set>
+                                      <p:cBhvr>
+                                        <p:cTn id="56" dur="1" fill="hold">
+                                          <p:stCondLst>
+                                            <p:cond delay="0"/>
+                                          </p:stCondLst>
+                                        </p:cTn>
+                                        <p:tgtEl>
+                                          <p:spTgt spid="24"/>
+                                        </p:tgtEl>
+                                        <p:attrNameLst>
+                                          <p:attrName>style.visibility</p:attrName>
+                                        </p:attrNameLst>
+                                      </p:cBhvr>
+                                      <p:to>
+                                        <p:strVal val="visible"/>
+                                      </p:to>
+                                    </p:set>
+                                    <p:animEffect transition="in" filter="fade">
+                                      <p:cBhvr>
+                                        <p:cTn id="57" dur="1000"/>
+                                        <p:tgtEl>
+                                          <p:spTgt spid="24"/>
+                                        </p:tgtEl>
+                                      </p:cBhvr>
+                                    </p:animEffect>
+                                    <p:anim calcmode="lin" valueType="num">
+                                      <p:cBhvr>
+                                        <p:cTn id="58" dur="1000" fill="hold"/>
+                                        <p:tgtEl>
+                                          <p:spTgt spid="24"/>
+                                        </p:tgtEl>
+                                        <p:attrNameLst>
+                                          <p:attrName>ppt_x</p:attrName>
+                                        </p:attrNameLst>
+                                      </p:cBhvr>
+                                      <p:tavLst>
+                                        <p:tav tm="0">
+                                          <p:val>
+                                            <p:strVal val="#ppt_x"/>
+                                          </p:val>
+                                        </p:tav>
+                                        <p:tav tm="100000">
+                                          <p:val>
+                                            <p:strVal val="#ppt_x"/>
+                                          </p:val>
+                                        </p:tav>
+                                      </p:tavLst>
+                                    </p:anim>
+                                    <p:anim calcmode="lin" valueType="num">
+                                      <p:cBhvr>
+                                        <p:cTn id="59" dur="1000" fill="hold"/>
+                                        <p:tgtEl>
+                                          <p:spTgt spid="24"/>
+                                        </p:tgtEl>
+                                        <p:attrNameLst>
+                                          <p:attrName>ppt_y</p:attrName>
+                                        </p:attrNameLst>
+                                      </p:cBhvr>
+                                      <p:tavLst>
+                                        <p:tav tm="0">
+                                          <p:val>
+                                            <p:strVal val="#ppt_y+.1"/>
+                                          </p:val>
+                                        </p:tav>
+                                        <p:tav tm="100000">
+                                          <p:val>
+                                            <p:strVal val="#ppt_y"/>
+                                          </p:val>
+                                        </p:tav>
+                                      </p:tavLst>
+                                    </p:anim>
+                                  </p:childTnLst>
+                                </p:cTn>
+                              </p:par>
+                            </p:childTnLst>
+                          </p:cTn>
+                        </p:par>
+                      </p:childTnLst>
+                    </p:cTn>
+                  </p:par>
+                  <p:par>
+                    <p:cTn id="60" fill="hold">
+                      <p:stCondLst>
+                        <p:cond delay="indefinite"/>
+                      </p:stCondLst>
+                      <p:childTnLst>
+                        <p:par>
+                          <p:cTn id="61" fill="hold">
+                            <p:stCondLst>
+                              <p:cond delay="0"/>
+                            </p:stCondLst>
+                            <p:childTnLst>
+                              <p:par>
+                                <p:cTn id="62" presetID="2" presetClass="entr" presetSubtype="4" fill="hold" grpId="0" nodeType="clickEffect">
+                                  <p:stCondLst>
+                                    <p:cond delay="0"/>
+                                  </p:stCondLst>
+                                  <p:childTnLst>
+                                    <p:set>
+                                      <p:cBhvr>
+                                        <p:cTn id="63" dur="1" fill="hold">
+                                          <p:stCondLst>
+                                            <p:cond delay="0"/>
+                                          </p:stCondLst>
+                                        </p:cTn>
+                                        <p:tgtEl>
+                                          <p:spTgt spid="22"/>
+                                        </p:tgtEl>
+                                        <p:attrNameLst>
+                                          <p:attrName>style.visibility</p:attrName>
+                                        </p:attrNameLst>
+                                      </p:cBhvr>
+                                      <p:to>
+                                        <p:strVal val="visible"/>
+                                      </p:to>
+                                    </p:set>
+                                    <p:anim calcmode="lin" valueType="num">
+                                      <p:cBhvr additive="base">
+                                        <p:cTn id="64" dur="500" fill="hold"/>
+                                        <p:tgtEl>
+                                          <p:spTgt spid="22"/>
+                                        </p:tgtEl>
+                                        <p:attrNameLst>
+                                          <p:attrName>ppt_x</p:attrName>
+                                        </p:attrNameLst>
+                                      </p:cBhvr>
+                                      <p:tavLst>
+                                        <p:tav tm="0">
+                                          <p:val>
+                                            <p:strVal val="#ppt_x"/>
+                                          </p:val>
+                                        </p:tav>
+                                        <p:tav tm="100000">
+                                          <p:val>
+                                            <p:strVal val="#ppt_x"/>
+                                          </p:val>
+                                        </p:tav>
+                                      </p:tavLst>
+                                    </p:anim>
+                                    <p:anim calcmode="lin" valueType="num">
+                                      <p:cBhvr additive="base">
+                                        <p:cTn id="65" dur="500" fill="hold"/>
+                                        <p:tgtEl>
+                                          <p:spTgt spid="22"/>
+                                        </p:tgtEl>
+                                        <p:attrNameLst>
+                                          <p:attrName>ppt_y</p:attrName>
+                                        </p:attrNameLst>
+                                      </p:cBhvr>
+                                      <p:tavLst>
+                                        <p:tav tm="0">
+                                          <p:val>
+                                            <p:strVal val="1+#ppt_h/2"/>
+                                          </p:val>
+                                        </p:tav>
+                                        <p:tav tm="100000">
+                                          <p:val>
+                                            <p:strVal val="#ppt_y"/>
+                                          </p:val>
+                                        </p:tav>
+                                      </p:tavLst>
+                                    </p:anim>
+                                  </p:childTnLst>
+                                </p:cTn>
+                              </p:par>
+                              <p:par>
+                                <p:cTn id="66" presetID="2" presetClass="entr" presetSubtype="4" fill="hold" grpId="0" nodeType="withEffect">
+                                  <p:stCondLst>
+                                    <p:cond delay="0"/>
+                                  </p:stCondLst>
+                                  <p:childTnLst>
+                                    <p:set>
+                                      <p:cBhvr>
+                                        <p:cTn id="67" dur="1" fill="hold">
+                                          <p:stCondLst>
+                                            <p:cond delay="0"/>
+                                          </p:stCondLst>
+                                        </p:cTn>
+                                        <p:tgtEl>
+                                          <p:spTgt spid="32"/>
+                                        </p:tgtEl>
+                                        <p:attrNameLst>
+                                          <p:attrName>style.visibility</p:attrName>
+                                        </p:attrNameLst>
+                                      </p:cBhvr>
+                                      <p:to>
+                                        <p:strVal val="visible"/>
+                                      </p:to>
+                                    </p:set>
+                                    <p:anim calcmode="lin" valueType="num">
+                                      <p:cBhvr additive="base">
+                                        <p:cTn id="68" dur="500" fill="hold"/>
+                                        <p:tgtEl>
+                                          <p:spTgt spid="32"/>
+                                        </p:tgtEl>
+                                        <p:attrNameLst>
+                                          <p:attrName>ppt_x</p:attrName>
+                                        </p:attrNameLst>
+                                      </p:cBhvr>
+                                      <p:tavLst>
+                                        <p:tav tm="0">
+                                          <p:val>
+                                            <p:strVal val="#ppt_x"/>
+                                          </p:val>
+                                        </p:tav>
+                                        <p:tav tm="100000">
+                                          <p:val>
+                                            <p:strVal val="#ppt_x"/>
+                                          </p:val>
+                                        </p:tav>
+                                      </p:tavLst>
+                                    </p:anim>
+                                    <p:anim calcmode="lin" valueType="num">
+                                      <p:cBhvr additive="base">
+                                        <p:cTn id="69" dur="500" fill="hold"/>
+                                        <p:tgtEl>
+                                          <p:spTgt spid="32"/>
+                                        </p:tgtEl>
+                                        <p:attrNameLst>
+                                          <p:attrName>ppt_y</p:attrName>
+                                        </p:attrNameLst>
+                                      </p:cBhvr>
+                                      <p:tavLst>
+                                        <p:tav tm="0">
+                                          <p:val>
+                                            <p:strVal val="1+#ppt_h/2"/>
+                                          </p:val>
+                                        </p:tav>
+                                        <p:tav tm="100000">
+                                          <p:val>
+                                            <p:strVal val="#ppt_y"/>
+                                          </p:val>
+                                        </p:tav>
+                                      </p:tavLst>
+                                    </p:anim>
+                                  </p:childTnLst>
+                                </p:cTn>
+                              </p:par>
+                            </p:childTnLst>
+                          </p:cTn>
+                        </p:par>
+                      </p:childTnLst>
+                    </p:cTn>
+                  </p:par>
+                  <p:par>
+                    <p:cTn id="70" fill="hold">
+                      <p:stCondLst>
+                        <p:cond delay="indefinite"/>
+                      </p:stCondLst>
+                      <p:childTnLst>
+                        <p:par>
+                          <p:cTn id="71" fill="hold">
+                            <p:stCondLst>
+                              <p:cond delay="0"/>
+                            </p:stCondLst>
+                            <p:childTnLst>
+                              <p:par>
+                                <p:cTn id="72" presetID="2" presetClass="entr" presetSubtype="4" fill="hold" grpId="0" nodeType="clickEffect">
+                                  <p:stCondLst>
+                                    <p:cond delay="0"/>
+                                  </p:stCondLst>
+                                  <p:childTnLst>
+                                    <p:set>
+                                      <p:cBhvr>
+                                        <p:cTn id="73" dur="1" fill="hold">
+                                          <p:stCondLst>
+                                            <p:cond delay="0"/>
+                                          </p:stCondLst>
+                                        </p:cTn>
+                                        <p:tgtEl>
+                                          <p:spTgt spid="33"/>
+                                        </p:tgtEl>
+                                        <p:attrNameLst>
+                                          <p:attrName>style.visibility</p:attrName>
+                                        </p:attrNameLst>
+                                      </p:cBhvr>
+                                      <p:to>
+                                        <p:strVal val="visible"/>
+                                      </p:to>
+                                    </p:set>
+                                    <p:anim calcmode="lin" valueType="num">
+                                      <p:cBhvr additive="base">
+                                        <p:cTn id="74" dur="500" fill="hold"/>
+                                        <p:tgtEl>
+                                          <p:spTgt spid="33"/>
+                                        </p:tgtEl>
+                                        <p:attrNameLst>
+                                          <p:attrName>ppt_x</p:attrName>
+                                        </p:attrNameLst>
+                                      </p:cBhvr>
+                                      <p:tavLst>
+                                        <p:tav tm="0">
+                                          <p:val>
+                                            <p:strVal val="#ppt_x"/>
+                                          </p:val>
+                                        </p:tav>
+                                        <p:tav tm="100000">
+                                          <p:val>
+                                            <p:strVal val="#ppt_x"/>
+                                          </p:val>
+                                        </p:tav>
+                                      </p:tavLst>
+                                    </p:anim>
+                                    <p:anim calcmode="lin" valueType="num">
+                                      <p:cBhvr additive="base">
+                                        <p:cTn id="75" dur="500" fill="hold"/>
+                                        <p:tgtEl>
+                                          <p:spTgt spid="33"/>
+                                        </p:tgtEl>
+                                        <p:attrNameLst>
+                                          <p:attrName>ppt_y</p:attrName>
+                                        </p:attrNameLst>
+                                      </p:cBhvr>
+                                      <p:tavLst>
+                                        <p:tav tm="0">
+                                          <p:val>
+                                            <p:strVal val="1+#ppt_h/2"/>
+                                          </p:val>
+                                        </p:tav>
+                                        <p:tav tm="100000">
+                                          <p:val>
+                                            <p:strVal val="#ppt_y"/>
+                                          </p:val>
+                                        </p:tav>
+                                      </p:tavLst>
+                                    </p:anim>
+                                  </p:childTnLst>
+                                </p:cTn>
+                              </p:par>
+                              <p:par>
+                                <p:cTn id="76" presetID="2" presetClass="entr" presetSubtype="4" fill="hold" grpId="0" nodeType="withEffect">
+                                  <p:stCondLst>
+                                    <p:cond delay="0"/>
+                                  </p:stCondLst>
+                                  <p:childTnLst>
+                                    <p:set>
+                                      <p:cBhvr>
+                                        <p:cTn id="77" dur="1" fill="hold">
+                                          <p:stCondLst>
+                                            <p:cond delay="0"/>
+                                          </p:stCondLst>
+                                        </p:cTn>
+                                        <p:tgtEl>
+                                          <p:spTgt spid="25"/>
+                                        </p:tgtEl>
+                                        <p:attrNameLst>
+                                          <p:attrName>style.visibility</p:attrName>
+                                        </p:attrNameLst>
+                                      </p:cBhvr>
+                                      <p:to>
+                                        <p:strVal val="visible"/>
+                                      </p:to>
+                                    </p:set>
+                                    <p:anim calcmode="lin" valueType="num">
+                                      <p:cBhvr additive="base">
+                                        <p:cTn id="78" dur="500" fill="hold"/>
+                                        <p:tgtEl>
+                                          <p:spTgt spid="25"/>
+                                        </p:tgtEl>
+                                        <p:attrNameLst>
+                                          <p:attrName>ppt_x</p:attrName>
+                                        </p:attrNameLst>
+                                      </p:cBhvr>
+                                      <p:tavLst>
+                                        <p:tav tm="0">
+                                          <p:val>
+                                            <p:strVal val="#ppt_x"/>
+                                          </p:val>
+                                        </p:tav>
+                                        <p:tav tm="100000">
+                                          <p:val>
+                                            <p:strVal val="#ppt_x"/>
+                                          </p:val>
+                                        </p:tav>
+                                      </p:tavLst>
+                                    </p:anim>
+                                    <p:anim calcmode="lin" valueType="num">
+                                      <p:cBhvr additive="base">
+                                        <p:cTn id="79" dur="500" fill="hold"/>
+                                        <p:tgtEl>
+                                          <p:spTgt spid="25"/>
+                                        </p:tgtEl>
+                                        <p:attrNameLst>
+                                          <p:attrName>ppt_y</p:attrName>
+                                        </p:attrNameLst>
+                                      </p:cBhvr>
+                                      <p:tavLst>
+                                        <p:tav tm="0">
+                                          <p:val>
+                                            <p:strVal val="1+#ppt_h/2"/>
+                                          </p:val>
+                                        </p:tav>
+                                        <p:tav tm="100000">
+                                          <p:val>
+                                            <p:strVal val="#ppt_y"/>
+                                          </p:val>
+                                        </p:tav>
+                                      </p:tavLst>
+                                    </p:anim>
+                                  </p:childTnLst>
+                                </p:cTn>
+                              </p:par>
+                            </p:childTnLst>
+                          </p:cTn>
+                        </p:par>
+                      </p:childTnLst>
+                    </p:cTn>
+                  </p:par>
+                  <p:par>
+                    <p:cTn id="80" fill="hold">
+                      <p:stCondLst>
+                        <p:cond delay="indefinite"/>
+                      </p:stCondLst>
+                      <p:childTnLst>
+                        <p:par>
+                          <p:cTn id="81" fill="hold">
+                            <p:stCondLst>
+                              <p:cond delay="0"/>
+                            </p:stCondLst>
+                            <p:childTnLst>
+                              <p:par>
+                                <p:cTn id="82" presetID="2" presetClass="entr" presetSubtype="4" fill="hold" grpId="0" nodeType="clickEffect">
+                                  <p:stCondLst>
+                                    <p:cond delay="0"/>
+                                  </p:stCondLst>
+                                  <p:childTnLst>
+                                    <p:set>
+                                      <p:cBhvr>
+                                        <p:cTn id="83" dur="1" fill="hold">
+                                          <p:stCondLst>
+                                            <p:cond delay="0"/>
+                                          </p:stCondLst>
+                                        </p:cTn>
+                                        <p:tgtEl>
+                                          <p:spTgt spid="28"/>
+                                        </p:tgtEl>
+                                        <p:attrNameLst>
+                                          <p:attrName>style.visibility</p:attrName>
+                                        </p:attrNameLst>
+                                      </p:cBhvr>
+                                      <p:to>
+                                        <p:strVal val="visible"/>
+                                      </p:to>
+                                    </p:set>
+                                    <p:anim calcmode="lin" valueType="num">
+                                      <p:cBhvr additive="base">
+                                        <p:cTn id="84" dur="500" fill="hold"/>
+                                        <p:tgtEl>
+                                          <p:spTgt spid="28"/>
+                                        </p:tgtEl>
+                                        <p:attrNameLst>
+                                          <p:attrName>ppt_x</p:attrName>
+                                        </p:attrNameLst>
+                                      </p:cBhvr>
+                                      <p:tavLst>
+                                        <p:tav tm="0">
+                                          <p:val>
+                                            <p:strVal val="#ppt_x"/>
+                                          </p:val>
+                                        </p:tav>
+                                        <p:tav tm="100000">
+                                          <p:val>
+                                            <p:strVal val="#ppt_x"/>
+                                          </p:val>
+                                        </p:tav>
+                                      </p:tavLst>
+                                    </p:anim>
+                                    <p:anim calcmode="lin" valueType="num">
+                                      <p:cBhvr additive="base">
+                                        <p:cTn id="85" dur="500" fill="hold"/>
+                                        <p:tgtEl>
+                                          <p:spTgt spid="28"/>
+                                        </p:tgtEl>
+                                        <p:attrNameLst>
+                                          <p:attrName>ppt_y</p:attrName>
+                                        </p:attrNameLst>
+                                      </p:cBhvr>
+                                      <p:tavLst>
+                                        <p:tav tm="0">
+                                          <p:val>
+                                            <p:strVal val="1+#ppt_h/2"/>
+                                          </p:val>
+                                        </p:tav>
+                                        <p:tav tm="100000">
+                                          <p:val>
+                                            <p:strVal val="#ppt_y"/>
+                                          </p:val>
+                                        </p:tav>
+                                      </p:tavLst>
+                                    </p:anim>
+                                  </p:childTnLst>
+                                </p:cTn>
+                              </p:par>
+                            </p:childTnLst>
+                          </p:cTn>
+                        </p:par>
+                      </p:childTnLst>
+                    </p:cTn>
+                  </p:par>
+                  <p:par>
+                    <p:cTn id="86" fill="hold">
+                      <p:stCondLst>
+                        <p:cond delay="indefinite"/>
+                      </p:stCondLst>
+                      <p:childTnLst>
+                        <p:par>
+                          <p:cTn id="87" fill="hold">
+                            <p:stCondLst>
+                              <p:cond delay="0"/>
+                            </p:stCondLst>
+                            <p:childTnLst>
+                              <p:par>
+                                <p:cTn id="88" presetID="2" presetClass="entr" presetSubtype="4" fill="hold" grpId="0" nodeType="clickEffect">
+                                  <p:stCondLst>
+                                    <p:cond delay="0"/>
+                                  </p:stCondLst>
+                                  <p:childTnLst>
+                                    <p:set>
+                                      <p:cBhvr>
+                                        <p:cTn id="89" dur="1" fill="hold">
+                                          <p:stCondLst>
+                                            <p:cond delay="0"/>
+                                          </p:stCondLst>
+                                        </p:cTn>
+                                        <p:tgtEl>
+                                          <p:spTgt spid="30"/>
+                                        </p:tgtEl>
+                                        <p:attrNameLst>
+                                          <p:attrName>style.visibility</p:attrName>
+                                        </p:attrNameLst>
+                                      </p:cBhvr>
+                                      <p:to>
+                                        <p:strVal val="visible"/>
+                                      </p:to>
+                                    </p:set>
+                                    <p:anim calcmode="lin" valueType="num">
+                                      <p:cBhvr additive="base">
+                                        <p:cTn id="90" dur="500" fill="hold"/>
+                                        <p:tgtEl>
+                                          <p:spTgt spid="30"/>
+                                        </p:tgtEl>
+                                        <p:attrNameLst>
+                                          <p:attrName>ppt_x</p:attrName>
+                                        </p:attrNameLst>
+                                      </p:cBhvr>
+                                      <p:tavLst>
+                                        <p:tav tm="0">
+                                          <p:val>
+                                            <p:strVal val="#ppt_x"/>
+                                          </p:val>
+                                        </p:tav>
+                                        <p:tav tm="100000">
+                                          <p:val>
+                                            <p:strVal val="#ppt_x"/>
+                                          </p:val>
+                                        </p:tav>
+                                      </p:tavLst>
+                                    </p:anim>
+                                    <p:anim calcmode="lin" valueType="num">
+                                      <p:cBhvr additive="base">
+                                        <p:cTn id="91" dur="500" fill="hold"/>
+                                        <p:tgtEl>
+                                          <p:spTgt spid="30"/>
+                                        </p:tgtEl>
+                                        <p:attrNameLst>
+                                          <p:attrName>ppt_y</p:attrName>
+                                        </p:attrNameLst>
+                                      </p:cBhvr>
+                                      <p:tavLst>
+                                        <p:tav tm="0">
+                                          <p:val>
+                                            <p:strVal val="1+#ppt_h/2"/>
+                                          </p:val>
+                                        </p:tav>
+                                        <p:tav tm="100000">
+                                          <p:val>
+                                            <p:strVal val="#ppt_y"/>
+                                          </p:val>
+                                        </p:tav>
+                                      </p:tavLst>
+                                    </p:anim>
+                                  </p:childTnLst>
+                                </p:cTn>
+                              </p:par>
+                              <p:par>
+                                <p:cTn id="92" presetID="2" presetClass="entr" presetSubtype="4" fill="hold" grpId="0" nodeType="withEffect">
+                                  <p:stCondLst>
+                                    <p:cond delay="0"/>
+                                  </p:stCondLst>
+                                  <p:childTnLst>
+                                    <p:set>
+                                      <p:cBhvr>
+                                        <p:cTn id="93" dur="1" fill="hold">
+                                          <p:stCondLst>
+                                            <p:cond delay="0"/>
+                                          </p:stCondLst>
+                                        </p:cTn>
+                                        <p:tgtEl>
+                                          <p:spTgt spid="29"/>
+                                        </p:tgtEl>
+                                        <p:attrNameLst>
+                                          <p:attrName>style.visibility</p:attrName>
+                                        </p:attrNameLst>
+                                      </p:cBhvr>
+                                      <p:to>
+                                        <p:strVal val="visible"/>
+                                      </p:to>
+                                    </p:set>
+                                    <p:anim calcmode="lin" valueType="num">
+                                      <p:cBhvr additive="base">
+                                        <p:cTn id="94" dur="500" fill="hold"/>
+                                        <p:tgtEl>
+                                          <p:spTgt spid="29"/>
+                                        </p:tgtEl>
+                                        <p:attrNameLst>
+                                          <p:attrName>ppt_x</p:attrName>
+                                        </p:attrNameLst>
+                                      </p:cBhvr>
+                                      <p:tavLst>
+                                        <p:tav tm="0">
+                                          <p:val>
+                                            <p:strVal val="#ppt_x"/>
+                                          </p:val>
+                                        </p:tav>
+                                        <p:tav tm="100000">
+                                          <p:val>
+                                            <p:strVal val="#ppt_x"/>
+                                          </p:val>
+                                        </p:tav>
+                                      </p:tavLst>
+                                    </p:anim>
+                                    <p:anim calcmode="lin" valueType="num">
+                                      <p:cBhvr additive="base">
+                                        <p:cTn id="95" dur="500" fill="hold"/>
+                                        <p:tgtEl>
+                                          <p:spTgt spid="29"/>
+                                        </p:tgtEl>
+                                        <p:attrNameLst>
+                                          <p:attrName>ppt_y</p:attrName>
+                                        </p:attrNameLst>
+                                      </p:cBhvr>
+                                      <p:tavLst>
+                                        <p:tav tm="0">
+                                          <p:val>
+                                            <p:strVal val="1+#ppt_h/2"/>
+                                          </p:val>
+                                        </p:tav>
+                                        <p:tav tm="100000">
+                                          <p:val>
+                                            <p:strVal val="#ppt_y"/>
+                                          </p:val>
+                                        </p:tav>
+                                      </p:tavLst>
+                                    </p:anim>
+                                  </p:childTnLst>
+                                </p:cTn>
+                              </p:par>
+                            </p:childTnLst>
+                          </p:cTn>
+                        </p:par>
+                      </p:childTnLst>
+                    </p:cTn>
+                  </p:par>
+                  <p:par>
+                    <p:cTn id="96" fill="hold">
+                      <p:stCondLst>
+                        <p:cond delay="indefinite"/>
+                      </p:stCondLst>
+                      <p:childTnLst>
+                        <p:par>
+                          <p:cTn id="97" fill="hold">
+                            <p:stCondLst>
+                              <p:cond delay="0"/>
+                            </p:stCondLst>
+                            <p:childTnLst>
+                              <p:par>
+                                <p:cTn id="98" presetID="2" presetClass="entr" presetSubtype="4" fill="hold" grpId="0" nodeType="clickEffect">
+                                  <p:stCondLst>
+                                    <p:cond delay="0"/>
+                                  </p:stCondLst>
+                                  <p:childTnLst>
+                                    <p:set>
+                                      <p:cBhvr>
+                                        <p:cTn id="99" dur="1" fill="hold">
+                                          <p:stCondLst>
+                                            <p:cond delay="0"/>
+                                          </p:stCondLst>
+                                        </p:cTn>
+                                        <p:tgtEl>
+                                          <p:spTgt spid="34"/>
+                                        </p:tgtEl>
+                                        <p:attrNameLst>
+                                          <p:attrName>style.visibility</p:attrName>
+                                        </p:attrNameLst>
+                                      </p:cBhvr>
+                                      <p:to>
+                                        <p:strVal val="visible"/>
+                                      </p:to>
+                                    </p:set>
+                                    <p:anim calcmode="lin" valueType="num">
+                                      <p:cBhvr additive="base">
+                                        <p:cTn id="100" dur="500" fill="hold"/>
+                                        <p:tgtEl>
+                                          <p:spTgt spid="34"/>
+                                        </p:tgtEl>
+                                        <p:attrNameLst>
+                                          <p:attrName>ppt_x</p:attrName>
+                                        </p:attrNameLst>
+                                      </p:cBhvr>
+                                      <p:tavLst>
+                                        <p:tav tm="0">
+                                          <p:val>
+                                            <p:strVal val="#ppt_x"/>
+                                          </p:val>
+                                        </p:tav>
+                                        <p:tav tm="100000">
+                                          <p:val>
+                                            <p:strVal val="#ppt_x"/>
+                                          </p:val>
+                                        </p:tav>
+                                      </p:tavLst>
+                                    </p:anim>
+                                    <p:anim calcmode="lin" valueType="num">
+                                      <p:cBhvr additive="base">
+                                        <p:cTn id="101" dur="500" fill="hold"/>
+                                        <p:tgtEl>
+                                          <p:spTgt spid="34"/>
+                                        </p:tgtEl>
+                                        <p:attrNameLst>
+                                          <p:attrName>ppt_y</p:attrName>
+                                        </p:attrNameLst>
+                                      </p:cBhvr>
+                                      <p:tavLst>
+                                        <p:tav tm="0">
+                                          <p:val>
+                                            <p:strVal val="1+#ppt_h/2"/>
+                                          </p:val>
+                                        </p:tav>
+                                        <p:tav tm="100000">
+                                          <p:val>
+                                            <p:strVal val="#ppt_y"/>
+                                          </p:val>
+                                        </p:tav>
+                                      </p:tavLst>
+                                    </p:anim>
+                                  </p:childTnLst>
+                                </p:cTn>
+                              </p:par>
+                            </p:childTnLst>
+                          </p:cTn>
+                        </p:par>
+                      </p:childTnLst>
+                    </p:cTn>
+                  </p:par>
+                  <p:par>
+                    <p:cTn id="102" fill="hold">
+                      <p:stCondLst>
+                        <p:cond delay="indefinite"/>
+                      </p:stCondLst>
+                      <p:childTnLst>
+                        <p:par>
+                          <p:cTn id="103" fill="hold">
+                            <p:stCondLst>
+                              <p:cond delay="0"/>
+                            </p:stCondLst>
+                            <p:childTnLst>
+                              <p:par>
+                                <p:cTn id="104" presetID="2" presetClass="entr" presetSubtype="4" fill="hold" grpId="0" nodeType="clickEffect">
+                                  <p:stCondLst>
+                                    <p:cond delay="0"/>
+                                  </p:stCondLst>
+                                  <p:childTnLst>
+                                    <p:set>
+                                      <p:cBhvr>
+                                        <p:cTn id="105" dur="1" fill="hold">
+                                          <p:stCondLst>
+                                            <p:cond delay="0"/>
+                                          </p:stCondLst>
+                                        </p:cTn>
+                                        <p:tgtEl>
+                                          <p:spTgt spid="35"/>
+                                        </p:tgtEl>
+                                        <p:attrNameLst>
+                                          <p:attrName>style.visibility</p:attrName>
+                                        </p:attrNameLst>
+                                      </p:cBhvr>
+                                      <p:to>
+                                        <p:strVal val="visible"/>
+                                      </p:to>
+                                    </p:set>
+                                    <p:anim calcmode="lin" valueType="num">
+                                      <p:cBhvr additive="base">
+                                        <p:cTn id="106" dur="500" fill="hold"/>
+                                        <p:tgtEl>
+                                          <p:spTgt spid="35"/>
+                                        </p:tgtEl>
+                                        <p:attrNameLst>
+                                          <p:attrName>ppt_x</p:attrName>
+                                        </p:attrNameLst>
+                                      </p:cBhvr>
+                                      <p:tavLst>
+                                        <p:tav tm="0">
+                                          <p:val>
+                                            <p:strVal val="#ppt_x"/>
+                                          </p:val>
+                                        </p:tav>
+                                        <p:tav tm="100000">
+                                          <p:val>
+                                            <p:strVal val="#ppt_x"/>
+                                          </p:val>
+                                        </p:tav>
+                                      </p:tavLst>
+                                    </p:anim>
+                                    <p:anim calcmode="lin" valueType="num">
+                                      <p:cBhvr additive="base">
+                                        <p:cTn id="107" dur="500" fill="hold"/>
+                                        <p:tgtEl>
+                                          <p:spTgt spid="35"/>
+                                        </p:tgtEl>
+                                        <p:attrNameLst>
+                                          <p:attrName>ppt_y</p:attrName>
+                                        </p:attrNameLst>
+                                      </p:cBhvr>
+                                      <p:tavLst>
+                                        <p:tav tm="0">
+                                          <p:val>
+                                            <p:strVal val="1+#ppt_h/2"/>
+                                          </p:val>
+                                        </p:tav>
+                                        <p:tav tm="100000">
+                                          <p:val>
+                                            <p:strVal val="#ppt_y"/>
+                                          </p:val>
+                                        </p:tav>
+                                      </p:tavLst>
+                                    </p:anim>
+                                  </p:childTnLst>
+                                </p:cTn>
+                              </p:par>
+                            </p:childTnLst>
+                          </p:cTn>
+                        </p:par>
+                      </p:childTnLst>
+                    </p:cTn>
+                  </p:par>
+                  <p:par>
+                    <p:cTn id="108" fill="hold">
+                      <p:stCondLst>
+                        <p:cond delay="indefinite"/>
+                      </p:stCondLst>
+                      <p:childTnLst>
+                        <p:par>
+                          <p:cTn id="109" fill="hold">
+                            <p:stCondLst>
+                              <p:cond delay="0"/>
+                            </p:stCondLst>
+                            <p:childTnLst>
+                              <p:par>
+                                <p:cTn id="110" presetID="2" presetClass="entr" presetSubtype="4" fill="hold" grpId="0" nodeType="clickEffect">
+                                  <p:stCondLst>
+                                    <p:cond delay="0"/>
+                                  </p:stCondLst>
+                                  <p:childTnLst>
+                                    <p:set>
+                                      <p:cBhvr>
+                                        <p:cTn id="111" dur="1" fill="hold">
+                                          <p:stCondLst>
+                                            <p:cond delay="0"/>
+                                          </p:stCondLst>
+                                        </p:cTn>
+                                        <p:tgtEl>
+                                          <p:spTgt spid="38"/>
+                                        </p:tgtEl>
+                                        <p:attrNameLst>
+                                          <p:attrName>style.visibility</p:attrName>
+                                        </p:attrNameLst>
+                                      </p:cBhvr>
+                                      <p:to>
+                                        <p:strVal val="visible"/>
+                                      </p:to>
+                                    </p:set>
+                                    <p:anim calcmode="lin" valueType="num">
+                                      <p:cBhvr additive="base">
+                                        <p:cTn id="112" dur="500" fill="hold"/>
+                                        <p:tgtEl>
+                                          <p:spTgt spid="38"/>
+                                        </p:tgtEl>
+                                        <p:attrNameLst>
+                                          <p:attrName>ppt_x</p:attrName>
+                                        </p:attrNameLst>
+                                      </p:cBhvr>
+                                      <p:tavLst>
+                                        <p:tav tm="0">
+                                          <p:val>
+                                            <p:strVal val="#ppt_x"/>
+                                          </p:val>
+                                        </p:tav>
+                                        <p:tav tm="100000">
+                                          <p:val>
+                                            <p:strVal val="#ppt_x"/>
+                                          </p:val>
+                                        </p:tav>
+                                      </p:tavLst>
+                                    </p:anim>
+                                    <p:anim calcmode="lin" valueType="num">
+                                      <p:cBhvr additive="base">
+                                        <p:cTn id="113" dur="500" fill="hold"/>
+                                        <p:tgtEl>
+                                          <p:spTgt spid="38"/>
+                                        </p:tgtEl>
+                                        <p:attrNameLst>
+                                          <p:attrName>ppt_y</p:attrName>
+                                        </p:attrNameLst>
+                                      </p:cBhvr>
+                                      <p:tavLst>
+                                        <p:tav tm="0">
+                                          <p:val>
+                                            <p:strVal val="1+#ppt_h/2"/>
+                                          </p:val>
+                                        </p:tav>
+                                        <p:tav tm="100000">
+                                          <p:val>
+                                            <p:strVal val="#ppt_y"/>
+                                          </p:val>
+                                        </p:tav>
+                                      </p:tavLst>
+                                    </p:anim>
+                                  </p:childTnLst>
+                                </p:cTn>
+                              </p:par>
+                            </p:childTnLst>
+                          </p:cTn>
+                        </p:par>
+                      </p:childTnLst>
+                    </p:cTn>
+                  </p:par>
+                  <p:par>
+                    <p:cTn id="114" fill="hold">
+                      <p:stCondLst>
+                        <p:cond delay="indefinite"/>
+                      </p:stCondLst>
+                      <p:childTnLst>
+                        <p:par>
+                          <p:cTn id="115" fill="hold">
+                            <p:stCondLst>
+                              <p:cond delay="0"/>
+                            </p:stCondLst>
+                            <p:childTnLst>
+                              <p:par>
+                                <p:cTn id="116" presetID="2" presetClass="entr" presetSubtype="4" fill="hold" grpId="0" nodeType="clickEffect">
+                                  <p:stCondLst>
+                                    <p:cond delay="0"/>
+                                  </p:stCondLst>
+                                  <p:childTnLst>
+                                    <p:set>
+                                      <p:cBhvr>
+                                        <p:cTn id="117" dur="1" fill="hold">
+                                          <p:stCondLst>
+                                            <p:cond delay="0"/>
+                                          </p:stCondLst>
+                                        </p:cTn>
+                                        <p:tgtEl>
+                                          <p:spTgt spid="40"/>
+                                        </p:tgtEl>
+                                        <p:attrNameLst>
+                                          <p:attrName>style.visibility</p:attrName>
+                                        </p:attrNameLst>
+                                      </p:cBhvr>
+                                      <p:to>
+                                        <p:strVal val="visible"/>
+                                      </p:to>
+                                    </p:set>
+                                    <p:anim calcmode="lin" valueType="num">
+                                      <p:cBhvr additive="base">
+                                        <p:cTn id="118" dur="500" fill="hold"/>
+                                        <p:tgtEl>
+                                          <p:spTgt spid="40"/>
+                                        </p:tgtEl>
+                                        <p:attrNameLst>
+                                          <p:attrName>ppt_x</p:attrName>
+                                        </p:attrNameLst>
+                                      </p:cBhvr>
+                                      <p:tavLst>
+                                        <p:tav tm="0">
+                                          <p:val>
+                                            <p:strVal val="#ppt_x"/>
+                                          </p:val>
+                                        </p:tav>
+                                        <p:tav tm="100000">
+                                          <p:val>
+                                            <p:strVal val="#ppt_x"/>
+                                          </p:val>
+                                        </p:tav>
+                                      </p:tavLst>
+                                    </p:anim>
+                                    <p:anim calcmode="lin" valueType="num">
+                                      <p:cBhvr additive="base">
+                                        <p:cTn id="119" dur="500" fill="hold"/>
+                                        <p:tgtEl>
+                                          <p:spTgt spid="40"/>
+                                        </p:tgtEl>
+                                        <p:attrNameLst>
+                                          <p:attrName>ppt_y</p:attrName>
+                                        </p:attrNameLst>
+                                      </p:cBhvr>
+                                      <p:tavLst>
+                                        <p:tav tm="0">
+                                          <p:val>
+                                            <p:strVal val="1+#ppt_h/2"/>
+                                          </p:val>
+                                        </p:tav>
+                                        <p:tav tm="100000">
+                                          <p:val>
+                                            <p:strVal val="#ppt_y"/>
+                                          </p:val>
+                                        </p:tav>
+                                      </p:tavLst>
+                                    </p:anim>
+                                  </p:childTnLst>
+                                </p:cTn>
+                              </p:par>
+                            </p:childTnLst>
+                          </p:cTn>
+                        </p:par>
+                      </p:childTnLst>
+                    </p:cTn>
+                  </p:par>
+                  <p:par>
+                    <p:cTn id="120" fill="hold">
+                      <p:stCondLst>
+                        <p:cond delay="indefinite"/>
+                      </p:stCondLst>
+                      <p:childTnLst>
+                        <p:par>
+                          <p:cTn id="121" fill="hold">
+                            <p:stCondLst>
+                              <p:cond delay="0"/>
+                            </p:stCondLst>
+                            <p:childTnLst>
+                              <p:par>
+                                <p:cTn id="122" presetID="2" presetClass="entr" presetSubtype="4" fill="hold" grpId="0" nodeType="clickEffect">
+                                  <p:stCondLst>
+                                    <p:cond delay="0"/>
+                                  </p:stCondLst>
+                                  <p:childTnLst>
+                                    <p:set>
+                                      <p:cBhvr>
+                                        <p:cTn id="123" dur="1" fill="hold">
+                                          <p:stCondLst>
+                                            <p:cond delay="0"/>
+                                          </p:stCondLst>
+                                        </p:cTn>
+                                        <p:tgtEl>
+                                          <p:spTgt spid="42"/>
+                                        </p:tgtEl>
+                                        <p:attrNameLst>
+                                          <p:attrName>style.visibility</p:attrName>
+                                        </p:attrNameLst>
+                                      </p:cBhvr>
+                                      <p:to>
+                                        <p:strVal val="visible"/>
+                                      </p:to>
+                                    </p:set>
+                                    <p:anim calcmode="lin" valueType="num">
+                                      <p:cBhvr additive="base">
+                                        <p:cTn id="124" dur="500" fill="hold"/>
+                                        <p:tgtEl>
+                                          <p:spTgt spid="42"/>
+                                        </p:tgtEl>
+                                        <p:attrNameLst>
+                                          <p:attrName>ppt_x</p:attrName>
+                                        </p:attrNameLst>
+                                      </p:cBhvr>
+                                      <p:tavLst>
+                                        <p:tav tm="0">
+                                          <p:val>
+                                            <p:strVal val="#ppt_x"/>
+                                          </p:val>
+                                        </p:tav>
+                                        <p:tav tm="100000">
+                                          <p:val>
+                                            <p:strVal val="#ppt_x"/>
+                                          </p:val>
+                                        </p:tav>
+                                      </p:tavLst>
+                                    </p:anim>
+                                    <p:anim calcmode="lin" valueType="num">
+                                      <p:cBhvr additive="base">
+                                        <p:cTn id="125" dur="500" fill="hold"/>
+                                        <p:tgtEl>
+                                          <p:spTgt spid="42"/>
+                                        </p:tgtEl>
+                                        <p:attrNameLst>
+                                          <p:attrName>ppt_y</p:attrName>
+                                        </p:attrNameLst>
+                                      </p:cBhvr>
+                                      <p:tavLst>
+                                        <p:tav tm="0">
+                                          <p:val>
+                                            <p:strVal val="1+#ppt_h/2"/>
+                                          </p:val>
+                                        </p:tav>
+                                        <p:tav tm="100000">
+                                          <p:val>
+                                            <p:strVal val="#ppt_y"/>
+                                          </p:val>
+                                        </p:tav>
+                                      </p:tavLst>
+                                    </p:anim>
+                                  </p:childTnLst>
+                                </p:cTn>
+                              </p:par>
+                              <p:par>
+                                <p:cTn id="126" presetID="2" presetClass="entr" presetSubtype="4" fill="hold" grpId="0" nodeType="withEffect">
+                                  <p:stCondLst>
+                                    <p:cond delay="0"/>
+                                  </p:stCondLst>
+                                  <p:childTnLst>
+                                    <p:set>
+                                      <p:cBhvr>
+                                        <p:cTn id="127" dur="1" fill="hold">
+                                          <p:stCondLst>
+                                            <p:cond delay="0"/>
+                                          </p:stCondLst>
+                                        </p:cTn>
+                                        <p:tgtEl>
+                                          <p:spTgt spid="57"/>
+                                        </p:tgtEl>
+                                        <p:attrNameLst>
+                                          <p:attrName>style.visibility</p:attrName>
+                                        </p:attrNameLst>
+                                      </p:cBhvr>
+                                      <p:to>
+                                        <p:strVal val="visible"/>
+                                      </p:to>
+                                    </p:set>
+                                    <p:anim calcmode="lin" valueType="num">
+                                      <p:cBhvr additive="base">
+                                        <p:cTn id="128" dur="500" fill="hold"/>
+                                        <p:tgtEl>
+                                          <p:spTgt spid="57"/>
+                                        </p:tgtEl>
+                                        <p:attrNameLst>
+                                          <p:attrName>ppt_x</p:attrName>
+                                        </p:attrNameLst>
+                                      </p:cBhvr>
+                                      <p:tavLst>
+                                        <p:tav tm="0">
+                                          <p:val>
+                                            <p:strVal val="#ppt_x"/>
+                                          </p:val>
+                                        </p:tav>
+                                        <p:tav tm="100000">
+                                          <p:val>
+                                            <p:strVal val="#ppt_x"/>
+                                          </p:val>
+                                        </p:tav>
+                                      </p:tavLst>
+                                    </p:anim>
+                                    <p:anim calcmode="lin" valueType="num">
+                                      <p:cBhvr additive="base">
+                                        <p:cTn id="129" dur="500" fill="hold"/>
+                                        <p:tgtEl>
+                                          <p:spTgt spid="57"/>
+                                        </p:tgtEl>
+                                        <p:attrNameLst>
+                                          <p:attrName>ppt_y</p:attrName>
+                                        </p:attrNameLst>
+                                      </p:cBhvr>
+                                      <p:tavLst>
+                                        <p:tav tm="0">
+                                          <p:val>
+                                            <p:strVal val="1+#ppt_h/2"/>
+                                          </p:val>
+                                        </p:tav>
+                                        <p:tav tm="100000">
+                                          <p:val>
+                                            <p:strVal val="#ppt_y"/>
+                                          </p:val>
+                                        </p:tav>
+                                      </p:tavLst>
+                                    </p:anim>
+                                  </p:childTnLst>
+                                </p:cTn>
+                              </p:par>
+                            </p:childTnLst>
+                          </p:cTn>
+                        </p:par>
+                      </p:childTnLst>
+                    </p:cTn>
+                  </p:par>
+                  <p:par>
+                    <p:cTn id="130" fill="hold">
+                      <p:stCondLst>
+                        <p:cond delay="indefinite"/>
+                      </p:stCondLst>
+                      <p:childTnLst>
+                        <p:par>
+                          <p:cTn id="131" fill="hold">
+                            <p:stCondLst>
+                              <p:cond delay="0"/>
+                            </p:stCondLst>
+                            <p:childTnLst>
+                              <p:par>
+                                <p:cTn id="132" presetID="2" presetClass="entr" presetSubtype="4" fill="hold" grpId="0" nodeType="clickEffect">
+                                  <p:stCondLst>
+                                    <p:cond delay="0"/>
+                                  </p:stCondLst>
+                                  <p:childTnLst>
+                                    <p:set>
+                                      <p:cBhvr>
+                                        <p:cTn id="133" dur="1" fill="hold">
+                                          <p:stCondLst>
+                                            <p:cond delay="0"/>
+                                          </p:stCondLst>
+                                        </p:cTn>
+                                        <p:tgtEl>
+                                          <p:spTgt spid="44"/>
+                                        </p:tgtEl>
+                                        <p:attrNameLst>
+                                          <p:attrName>style.visibility</p:attrName>
+                                        </p:attrNameLst>
+                                      </p:cBhvr>
+                                      <p:to>
+                                        <p:strVal val="visible"/>
+                                      </p:to>
+                                    </p:set>
+                                    <p:anim calcmode="lin" valueType="num">
+                                      <p:cBhvr additive="base">
+                                        <p:cTn id="134" dur="500" fill="hold"/>
+                                        <p:tgtEl>
+                                          <p:spTgt spid="44"/>
+                                        </p:tgtEl>
+                                        <p:attrNameLst>
+                                          <p:attrName>ppt_x</p:attrName>
+                                        </p:attrNameLst>
+                                      </p:cBhvr>
+                                      <p:tavLst>
+                                        <p:tav tm="0">
+                                          <p:val>
+                                            <p:strVal val="#ppt_x"/>
+                                          </p:val>
+                                        </p:tav>
+                                        <p:tav tm="100000">
+                                          <p:val>
+                                            <p:strVal val="#ppt_x"/>
+                                          </p:val>
+                                        </p:tav>
+                                      </p:tavLst>
+                                    </p:anim>
+                                    <p:anim calcmode="lin" valueType="num">
+                                      <p:cBhvr additive="base">
+                                        <p:cTn id="135" dur="500" fill="hold"/>
+                                        <p:tgtEl>
+                                          <p:spTgt spid="44"/>
+                                        </p:tgtEl>
+                                        <p:attrNameLst>
+                                          <p:attrName>ppt_y</p:attrName>
+                                        </p:attrNameLst>
+                                      </p:cBhvr>
+                                      <p:tavLst>
+                                        <p:tav tm="0">
+                                          <p:val>
+                                            <p:strVal val="1+#ppt_h/2"/>
+                                          </p:val>
+                                        </p:tav>
+                                        <p:tav tm="100000">
+                                          <p:val>
+                                            <p:strVal val="#ppt_y"/>
+                                          </p:val>
+                                        </p:tav>
+                                      </p:tavLst>
+                                    </p:anim>
+                                  </p:childTnLst>
+                                </p:cTn>
+                              </p:par>
+                              <p:par>
+                                <p:cTn id="136" presetID="2" presetClass="entr" presetSubtype="4" fill="hold" grpId="0" nodeType="withEffect">
+                                  <p:stCondLst>
+                                    <p:cond delay="0"/>
+                                  </p:stCondLst>
+                                  <p:childTnLst>
+                                    <p:set>
+                                      <p:cBhvr>
+                                        <p:cTn id="137" dur="1" fill="hold">
+                                          <p:stCondLst>
+                                            <p:cond delay="0"/>
+                                          </p:stCondLst>
+                                        </p:cTn>
+                                        <p:tgtEl>
+                                          <p:spTgt spid="58"/>
+                                        </p:tgtEl>
+                                        <p:attrNameLst>
+                                          <p:attrName>style.visibility</p:attrName>
+                                        </p:attrNameLst>
+                                      </p:cBhvr>
+                                      <p:to>
+                                        <p:strVal val="visible"/>
+                                      </p:to>
+                                    </p:set>
+                                    <p:anim calcmode="lin" valueType="num">
+                                      <p:cBhvr additive="base">
+                                        <p:cTn id="138" dur="500" fill="hold"/>
+                                        <p:tgtEl>
+                                          <p:spTgt spid="58"/>
+                                        </p:tgtEl>
+                                        <p:attrNameLst>
+                                          <p:attrName>ppt_x</p:attrName>
+                                        </p:attrNameLst>
+                                      </p:cBhvr>
+                                      <p:tavLst>
+                                        <p:tav tm="0">
+                                          <p:val>
+                                            <p:strVal val="#ppt_x"/>
+                                          </p:val>
+                                        </p:tav>
+                                        <p:tav tm="100000">
+                                          <p:val>
+                                            <p:strVal val="#ppt_x"/>
+                                          </p:val>
+                                        </p:tav>
+                                      </p:tavLst>
+                                    </p:anim>
+                                    <p:anim calcmode="lin" valueType="num">
+                                      <p:cBhvr additive="base">
+                                        <p:cTn id="139" dur="500" fill="hold"/>
+                                        <p:tgtEl>
+                                          <p:spTgt spid="58"/>
+                                        </p:tgtEl>
+                                        <p:attrNameLst>
+                                          <p:attrName>ppt_y</p:attrName>
+                                        </p:attrNameLst>
+                                      </p:cBhvr>
+                                      <p:tavLst>
+                                        <p:tav tm="0">
+                                          <p:val>
+                                            <p:strVal val="1+#ppt_h/2"/>
+                                          </p:val>
+                                        </p:tav>
+                                        <p:tav tm="100000">
+                                          <p:val>
+                                            <p:strVal val="#ppt_y"/>
+                                          </p:val>
+                                        </p:tav>
+                                      </p:tavLst>
+                                    </p:anim>
+                                  </p:childTnLst>
+                                </p:cTn>
+                              </p:par>
+                            </p:childTnLst>
+                          </p:cTn>
+                        </p:par>
+                      </p:childTnLst>
+                    </p:cTn>
+                  </p:par>
+                  <p:par>
+                    <p:cTn id="140" fill="hold">
+                      <p:stCondLst>
+                        <p:cond delay="indefinite"/>
+                      </p:stCondLst>
+                      <p:childTnLst>
+                        <p:par>
+                          <p:cTn id="141" fill="hold">
+                            <p:stCondLst>
+                              <p:cond delay="0"/>
+                            </p:stCondLst>
+                            <p:childTnLst>
+                              <p:par>
+                                <p:cTn id="142" presetID="2" presetClass="entr" presetSubtype="4" fill="hold" grpId="0" nodeType="clickEffect">
+                                  <p:stCondLst>
+                                    <p:cond delay="0"/>
+                                  </p:stCondLst>
+                                  <p:childTnLst>
+                                    <p:set>
+                                      <p:cBhvr>
+                                        <p:cTn id="143" dur="1" fill="hold">
+                                          <p:stCondLst>
+                                            <p:cond delay="0"/>
+                                          </p:stCondLst>
+                                        </p:cTn>
+                                        <p:tgtEl>
+                                          <p:spTgt spid="47"/>
+                                        </p:tgtEl>
+                                        <p:attrNameLst>
+                                          <p:attrName>style.visibility</p:attrName>
+                                        </p:attrNameLst>
+                                      </p:cBhvr>
+                                      <p:to>
+                                        <p:strVal val="visible"/>
+                                      </p:to>
+                                    </p:set>
+                                    <p:anim calcmode="lin" valueType="num">
+                                      <p:cBhvr additive="base">
+                                        <p:cTn id="144" dur="500" fill="hold"/>
+                                        <p:tgtEl>
+                                          <p:spTgt spid="47"/>
+                                        </p:tgtEl>
+                                        <p:attrNameLst>
+                                          <p:attrName>ppt_x</p:attrName>
+                                        </p:attrNameLst>
+                                      </p:cBhvr>
+                                      <p:tavLst>
+                                        <p:tav tm="0">
+                                          <p:val>
+                                            <p:strVal val="#ppt_x"/>
+                                          </p:val>
+                                        </p:tav>
+                                        <p:tav tm="100000">
+                                          <p:val>
+                                            <p:strVal val="#ppt_x"/>
+                                          </p:val>
+                                        </p:tav>
+                                      </p:tavLst>
+                                    </p:anim>
+                                    <p:anim calcmode="lin" valueType="num">
+                                      <p:cBhvr additive="base">
+                                        <p:cTn id="145" dur="500" fill="hold"/>
+                                        <p:tgtEl>
+                                          <p:spTgt spid="47"/>
+                                        </p:tgtEl>
+                                        <p:attrNameLst>
+                                          <p:attrName>ppt_y</p:attrName>
+                                        </p:attrNameLst>
+                                      </p:cBhvr>
+                                      <p:tavLst>
+                                        <p:tav tm="0">
+                                          <p:val>
+                                            <p:strVal val="1+#ppt_h/2"/>
+                                          </p:val>
+                                        </p:tav>
+                                        <p:tav tm="100000">
+                                          <p:val>
+                                            <p:strVal val="#ppt_y"/>
+                                          </p:val>
+                                        </p:tav>
+                                      </p:tavLst>
+                                    </p:anim>
+                                  </p:childTnLst>
+                                </p:cTn>
+                              </p:par>
+                              <p:par>
+                                <p:cTn id="146" presetID="2" presetClass="entr" presetSubtype="4" fill="hold" grpId="0" nodeType="withEffect">
+                                  <p:stCondLst>
+                                    <p:cond delay="0"/>
+                                  </p:stCondLst>
+                                  <p:childTnLst>
+                                    <p:set>
+                                      <p:cBhvr>
+                                        <p:cTn id="147" dur="1" fill="hold">
+                                          <p:stCondLst>
+                                            <p:cond delay="0"/>
+                                          </p:stCondLst>
+                                        </p:cTn>
+                                        <p:tgtEl>
+                                          <p:spTgt spid="59"/>
+                                        </p:tgtEl>
+                                        <p:attrNameLst>
+                                          <p:attrName>style.visibility</p:attrName>
+                                        </p:attrNameLst>
+                                      </p:cBhvr>
+                                      <p:to>
+                                        <p:strVal val="visible"/>
+                                      </p:to>
+                                    </p:set>
+                                    <p:anim calcmode="lin" valueType="num">
+                                      <p:cBhvr additive="base">
+                                        <p:cTn id="148" dur="500" fill="hold"/>
+                                        <p:tgtEl>
+                                          <p:spTgt spid="59"/>
+                                        </p:tgtEl>
+                                        <p:attrNameLst>
+                                          <p:attrName>ppt_x</p:attrName>
+                                        </p:attrNameLst>
+                                      </p:cBhvr>
+                                      <p:tavLst>
+                                        <p:tav tm="0">
+                                          <p:val>
+                                            <p:strVal val="#ppt_x"/>
+                                          </p:val>
+                                        </p:tav>
+                                        <p:tav tm="100000">
+                                          <p:val>
+                                            <p:strVal val="#ppt_x"/>
+                                          </p:val>
+                                        </p:tav>
+                                      </p:tavLst>
+                                    </p:anim>
+                                    <p:anim calcmode="lin" valueType="num">
+                                      <p:cBhvr additive="base">
+                                        <p:cTn id="149" dur="500" fill="hold"/>
+                                        <p:tgtEl>
+                                          <p:spTgt spid="59"/>
+                                        </p:tgtEl>
+                                        <p:attrNameLst>
+                                          <p:attrName>ppt_y</p:attrName>
+                                        </p:attrNameLst>
+                                      </p:cBhvr>
+                                      <p:tavLst>
+                                        <p:tav tm="0">
+                                          <p:val>
+                                            <p:strVal val="1+#ppt_h/2"/>
+                                          </p:val>
+                                        </p:tav>
+                                        <p:tav tm="100000">
+                                          <p:val>
+                                            <p:strVal val="#ppt_y"/>
+                                          </p:val>
+                                        </p:tav>
+                                      </p:tavLst>
+                                    </p:anim>
+                                  </p:childTnLst>
+                                </p:cTn>
+                              </p:par>
+                            </p:childTnLst>
+                          </p:cTn>
+                        </p:par>
+                      </p:childTnLst>
+                    </p:cTn>
+                  </p:par>
+                  <p:par>
+                    <p:cTn id="150" fill="hold">
+                      <p:stCondLst>
+                        <p:cond delay="indefinite"/>
+                      </p:stCondLst>
+                      <p:childTnLst>
+                        <p:par>
+                          <p:cTn id="151" fill="hold">
+                            <p:stCondLst>
+                              <p:cond delay="0"/>
+                            </p:stCondLst>
+                            <p:childTnLst>
+                              <p:par>
+                                <p:cTn id="152" presetID="2" presetClass="entr" presetSubtype="4" fill="hold" grpId="0" nodeType="clickEffect">
+                                  <p:stCondLst>
+                                    <p:cond delay="0"/>
+                                  </p:stCondLst>
+                                  <p:childTnLst>
+                                    <p:set>
+                                      <p:cBhvr>
+                                        <p:cTn id="153" dur="1" fill="hold">
+                                          <p:stCondLst>
+                                            <p:cond delay="0"/>
+                                          </p:stCondLst>
+                                        </p:cTn>
+                                        <p:tgtEl>
+                                          <p:spTgt spid="49"/>
+                                        </p:tgtEl>
+                                        <p:attrNameLst>
+                                          <p:attrName>style.visibility</p:attrName>
+                                        </p:attrNameLst>
+                                      </p:cBhvr>
+                                      <p:to>
+                                        <p:strVal val="visible"/>
+                                      </p:to>
+                                    </p:set>
+                                    <p:anim calcmode="lin" valueType="num">
+                                      <p:cBhvr additive="base">
+                                        <p:cTn id="154" dur="500" fill="hold"/>
+                                        <p:tgtEl>
+                                          <p:spTgt spid="49"/>
+                                        </p:tgtEl>
+                                        <p:attrNameLst>
+                                          <p:attrName>ppt_x</p:attrName>
+                                        </p:attrNameLst>
+                                      </p:cBhvr>
+                                      <p:tavLst>
+                                        <p:tav tm="0">
+                                          <p:val>
+                                            <p:strVal val="#ppt_x"/>
+                                          </p:val>
+                                        </p:tav>
+                                        <p:tav tm="100000">
+                                          <p:val>
+                                            <p:strVal val="#ppt_x"/>
+                                          </p:val>
+                                        </p:tav>
+                                      </p:tavLst>
+                                    </p:anim>
+                                    <p:anim calcmode="lin" valueType="num">
+                                      <p:cBhvr additive="base">
+                                        <p:cTn id="155" dur="500" fill="hold"/>
+                                        <p:tgtEl>
+                                          <p:spTgt spid="49"/>
+                                        </p:tgtEl>
+                                        <p:attrNameLst>
+                                          <p:attrName>ppt_y</p:attrName>
+                                        </p:attrNameLst>
+                                      </p:cBhvr>
+                                      <p:tavLst>
+                                        <p:tav tm="0">
+                                          <p:val>
+                                            <p:strVal val="1+#ppt_h/2"/>
+                                          </p:val>
+                                        </p:tav>
+                                        <p:tav tm="100000">
+                                          <p:val>
+                                            <p:strVal val="#ppt_y"/>
+                                          </p:val>
+                                        </p:tav>
+                                      </p:tavLst>
+                                    </p:anim>
+                                  </p:childTnLst>
+                                </p:cTn>
+                              </p:par>
+                              <p:par>
+                                <p:cTn id="156" presetID="2" presetClass="entr" presetSubtype="4" fill="hold" grpId="0" nodeType="withEffect">
+                                  <p:stCondLst>
+                                    <p:cond delay="0"/>
+                                  </p:stCondLst>
+                                  <p:childTnLst>
+                                    <p:set>
+                                      <p:cBhvr>
+                                        <p:cTn id="157" dur="1" fill="hold">
+                                          <p:stCondLst>
+                                            <p:cond delay="0"/>
+                                          </p:stCondLst>
+                                        </p:cTn>
+                                        <p:tgtEl>
+                                          <p:spTgt spid="55"/>
+                                        </p:tgtEl>
+                                        <p:attrNameLst>
+                                          <p:attrName>style.visibility</p:attrName>
+                                        </p:attrNameLst>
+                                      </p:cBhvr>
+                                      <p:to>
+                                        <p:strVal val="visible"/>
+                                      </p:to>
+                                    </p:set>
+                                    <p:anim calcmode="lin" valueType="num">
+                                      <p:cBhvr additive="base">
+                                        <p:cTn id="158" dur="500" fill="hold"/>
+                                        <p:tgtEl>
+                                          <p:spTgt spid="55"/>
+                                        </p:tgtEl>
+                                        <p:attrNameLst>
+                                          <p:attrName>ppt_x</p:attrName>
+                                        </p:attrNameLst>
+                                      </p:cBhvr>
+                                      <p:tavLst>
+                                        <p:tav tm="0">
+                                          <p:val>
+                                            <p:strVal val="#ppt_x"/>
+                                          </p:val>
+                                        </p:tav>
+                                        <p:tav tm="100000">
+                                          <p:val>
+                                            <p:strVal val="#ppt_x"/>
+                                          </p:val>
+                                        </p:tav>
+                                      </p:tavLst>
+                                    </p:anim>
+                                    <p:anim calcmode="lin" valueType="num">
+                                      <p:cBhvr additive="base">
+                                        <p:cTn id="159" dur="500" fill="hold"/>
+                                        <p:tgtEl>
+                                          <p:spTgt spid="55"/>
+                                        </p:tgtEl>
+                                        <p:attrNameLst>
+                                          <p:attrName>ppt_y</p:attrName>
+                                        </p:attrNameLst>
+                                      </p:cBhvr>
+                                      <p:tavLst>
+                                        <p:tav tm="0">
+                                          <p:val>
+                                            <p:strVal val="1+#ppt_h/2"/>
+                                          </p:val>
+                                        </p:tav>
+                                        <p:tav tm="100000">
+                                          <p:val>
+                                            <p:strVal val="#ppt_y"/>
+                                          </p:val>
+                                        </p:tav>
+                                      </p:tavLst>
+                                    </p:anim>
+                                  </p:childTnLst>
+                                </p:cTn>
+                              </p:par>
+                            </p:childTnLst>
+                          </p:cTn>
+                        </p:par>
+                      </p:childTnLst>
+                    </p:cTn>
+                  </p:par>
+                  <p:par>
+                    <p:cTn id="160" fill="hold">
+                      <p:stCondLst>
+                        <p:cond delay="indefinite"/>
+                      </p:stCondLst>
+                      <p:childTnLst>
+                        <p:par>
+                          <p:cTn id="161" fill="hold">
+                            <p:stCondLst>
+                              <p:cond delay="0"/>
+                            </p:stCondLst>
+                            <p:childTnLst>
+                              <p:par>
+                                <p:cTn id="162" presetID="2" presetClass="entr" presetSubtype="4" fill="hold" grpId="0" nodeType="clickEffect">
+                                  <p:stCondLst>
+                                    <p:cond delay="0"/>
+                                  </p:stCondLst>
+                                  <p:childTnLst>
+                                    <p:set>
+                                      <p:cBhvr>
+                                        <p:cTn id="163" dur="1" fill="hold">
+                                          <p:stCondLst>
+                                            <p:cond delay="0"/>
+                                          </p:stCondLst>
+                                        </p:cTn>
+                                        <p:tgtEl>
+                                          <p:spTgt spid="50"/>
+                                        </p:tgtEl>
+                                        <p:attrNameLst>
+                                          <p:attrName>style.visibility</p:attrName>
+                                        </p:attrNameLst>
+                                      </p:cBhvr>
+                                      <p:to>
+                                        <p:strVal val="visible"/>
+                                      </p:to>
+                                    </p:set>
+                                    <p:anim calcmode="lin" valueType="num">
+                                      <p:cBhvr additive="base">
+                                        <p:cTn id="164" dur="500" fill="hold"/>
+                                        <p:tgtEl>
+                                          <p:spTgt spid="50"/>
+                                        </p:tgtEl>
+                                        <p:attrNameLst>
+                                          <p:attrName>ppt_x</p:attrName>
+                                        </p:attrNameLst>
+                                      </p:cBhvr>
+                                      <p:tavLst>
+                                        <p:tav tm="0">
+                                          <p:val>
+                                            <p:strVal val="#ppt_x"/>
+                                          </p:val>
+                                        </p:tav>
+                                        <p:tav tm="100000">
+                                          <p:val>
+                                            <p:strVal val="#ppt_x"/>
+                                          </p:val>
+                                        </p:tav>
+                                      </p:tavLst>
+                                    </p:anim>
+                                    <p:anim calcmode="lin" valueType="num">
+                                      <p:cBhvr additive="base">
+                                        <p:cTn id="165" dur="500" fill="hold"/>
+                                        <p:tgtEl>
+                                          <p:spTgt spid="50"/>
+                                        </p:tgtEl>
+                                        <p:attrNameLst>
+                                          <p:attrName>ppt_y</p:attrName>
+                                        </p:attrNameLst>
+                                      </p:cBhvr>
+                                      <p:tavLst>
+                                        <p:tav tm="0">
+                                          <p:val>
+                                            <p:strVal val="1+#ppt_h/2"/>
+                                          </p:val>
+                                        </p:tav>
+                                        <p:tav tm="100000">
+                                          <p:val>
+                                            <p:strVal val="#ppt_y"/>
+                                          </p:val>
+                                        </p:tav>
+                                      </p:tavLst>
+                                    </p:anim>
+                                  </p:childTnLst>
+                                </p:cTn>
+                              </p:par>
+                              <p:par>
+                                <p:cTn id="166" presetID="2" presetClass="entr" presetSubtype="4" fill="hold" grpId="0" nodeType="withEffect">
+                                  <p:stCondLst>
+                                    <p:cond delay="0"/>
+                                  </p:stCondLst>
+                                  <p:childTnLst>
+                                    <p:set>
+                                      <p:cBhvr>
+                                        <p:cTn id="167" dur="1" fill="hold">
+                                          <p:stCondLst>
+                                            <p:cond delay="0"/>
+                                          </p:stCondLst>
+                                        </p:cTn>
+                                        <p:tgtEl>
+                                          <p:spTgt spid="56"/>
+                                        </p:tgtEl>
+                                        <p:attrNameLst>
+                                          <p:attrName>style.visibility</p:attrName>
+                                        </p:attrNameLst>
+                                      </p:cBhvr>
+                                      <p:to>
+                                        <p:strVal val="visible"/>
+                                      </p:to>
+                                    </p:set>
+                                    <p:anim calcmode="lin" valueType="num">
+                                      <p:cBhvr additive="base">
+                                        <p:cTn id="168" dur="500" fill="hold"/>
+                                        <p:tgtEl>
+                                          <p:spTgt spid="56"/>
+                                        </p:tgtEl>
+                                        <p:attrNameLst>
+                                          <p:attrName>ppt_x</p:attrName>
+                                        </p:attrNameLst>
+                                      </p:cBhvr>
+                                      <p:tavLst>
+                                        <p:tav tm="0">
+                                          <p:val>
+                                            <p:strVal val="#ppt_x"/>
+                                          </p:val>
+                                        </p:tav>
+                                        <p:tav tm="100000">
+                                          <p:val>
+                                            <p:strVal val="#ppt_x"/>
+                                          </p:val>
+                                        </p:tav>
+                                      </p:tavLst>
+                                    </p:anim>
+                                    <p:anim calcmode="lin" valueType="num">
+                                      <p:cBhvr additive="base">
+                                        <p:cTn id="169" dur="500" fill="hold"/>
+                                        <p:tgtEl>
+                                          <p:spTgt spid="56"/>
+                                        </p:tgtEl>
+                                        <p:attrNameLst>
+                                          <p:attrName>ppt_y</p:attrName>
+                                        </p:attrNameLst>
+                                      </p:cBhvr>
+                                      <p:tavLst>
+                                        <p:tav tm="0">
+                                          <p:val>
+                                            <p:strVal val="1+#ppt_h/2"/>
+                                          </p:val>
+                                        </p:tav>
+                                        <p:tav tm="100000">
+                                          <p:val>
+                                            <p:strVal val="#ppt_y"/>
+                                          </p:val>
+                                        </p:tav>
+                                      </p:tavLst>
+                                    </p:anim>
+                                  </p:childTnLst>
+                                </p:cTn>
+                              </p:par>
+                            </p:childTnLst>
+                          </p:cTn>
+                        </p:par>
+                      </p:childTnLst>
+                    </p:cTn>
+                  </p:par>
+                  <p:par>
+                    <p:cTn id="170" fill="hold">
+                      <p:stCondLst>
+                        <p:cond delay="indefinite"/>
+                      </p:stCondLst>
+                      <p:childTnLst>
+                        <p:par>
+                          <p:cTn id="171" fill="hold">
+                            <p:stCondLst>
+                              <p:cond delay="0"/>
+                            </p:stCondLst>
+                            <p:childTnLst>
+                              <p:par>
+                                <p:cTn id="172" presetID="2" presetClass="entr" presetSubtype="4" fill="hold" grpId="0" nodeType="clickEffect">
+                                  <p:stCondLst>
+                                    <p:cond delay="0"/>
+                                  </p:stCondLst>
+                                  <p:childTnLst>
+                                    <p:set>
+                                      <p:cBhvr>
+                                        <p:cTn id="173" dur="1" fill="hold">
+                                          <p:stCondLst>
+                                            <p:cond delay="0"/>
+                                          </p:stCondLst>
+                                        </p:cTn>
+                                        <p:tgtEl>
+                                          <p:spTgt spid="52"/>
+                                        </p:tgtEl>
+                                        <p:attrNameLst>
+                                          <p:attrName>style.visibility</p:attrName>
+                                        </p:attrNameLst>
+                                      </p:cBhvr>
+                                      <p:to>
+                                        <p:strVal val="visible"/>
+                                      </p:to>
+                                    </p:set>
+                                    <p:anim calcmode="lin" valueType="num">
+                                      <p:cBhvr additive="base">
+                                        <p:cTn id="174" dur="500" fill="hold"/>
+                                        <p:tgtEl>
+                                          <p:spTgt spid="52"/>
+                                        </p:tgtEl>
+                                        <p:attrNameLst>
+                                          <p:attrName>ppt_x</p:attrName>
+                                        </p:attrNameLst>
+                                      </p:cBhvr>
+                                      <p:tavLst>
+                                        <p:tav tm="0">
+                                          <p:val>
+                                            <p:strVal val="#ppt_x"/>
+                                          </p:val>
+                                        </p:tav>
+                                        <p:tav tm="100000">
+                                          <p:val>
+                                            <p:strVal val="#ppt_x"/>
+                                          </p:val>
+                                        </p:tav>
+                                      </p:tavLst>
+                                    </p:anim>
+                                    <p:anim calcmode="lin" valueType="num">
+                                      <p:cBhvr additive="base">
+                                        <p:cTn id="175" dur="500" fill="hold"/>
+                                        <p:tgtEl>
+                                          <p:spTgt spid="52"/>
+                                        </p:tgtEl>
+                                        <p:attrNameLst>
+                                          <p:attrName>ppt_y</p:attrName>
+                                        </p:attrNameLst>
+                                      </p:cBhvr>
+                                      <p:tavLst>
+                                        <p:tav tm="0">
+                                          <p:val>
+                                            <p:strVal val="1+#ppt_h/2"/>
+                                          </p:val>
+                                        </p:tav>
+                                        <p:tav tm="100000">
+                                          <p:val>
+                                            <p:strVal val="#ppt_y"/>
+                                          </p:val>
+                                        </p:tav>
+                                      </p:tavLst>
+                                    </p:anim>
+                                  </p:childTnLst>
+                                </p:cTn>
+                              </p:par>
+                            </p:childTnLst>
+                          </p:cTn>
+                        </p:par>
+                      </p:childTnLst>
+                    </p:cTn>
+                  </p:par>
+                  <p:par>
+                    <p:cTn id="176" fill="hold">
+                      <p:stCondLst>
+                        <p:cond delay="indefinite"/>
+                      </p:stCondLst>
+                      <p:childTnLst>
+                        <p:par>
+                          <p:cTn id="177" fill="hold">
+                            <p:stCondLst>
+                              <p:cond delay="0"/>
+                            </p:stCondLst>
+                            <p:childTnLst>
+                              <p:par>
+                                <p:cTn id="178" presetID="2" presetClass="entr" presetSubtype="4" fill="hold" grpId="0" nodeType="clickEffect">
+                                  <p:stCondLst>
+                                    <p:cond delay="0"/>
+                                  </p:stCondLst>
+                                  <p:childTnLst>
+                                    <p:set>
+                                      <p:cBhvr>
+                                        <p:cTn id="179" dur="1" fill="hold">
+                                          <p:stCondLst>
+                                            <p:cond delay="0"/>
+                                          </p:stCondLst>
+                                        </p:cTn>
+                                        <p:tgtEl>
+                                          <p:spTgt spid="53"/>
+                                        </p:tgtEl>
+                                        <p:attrNameLst>
+                                          <p:attrName>style.visibility</p:attrName>
+                                        </p:attrNameLst>
+                                      </p:cBhvr>
+                                      <p:to>
+                                        <p:strVal val="visible"/>
+                                      </p:to>
+                                    </p:set>
+                                    <p:anim calcmode="lin" valueType="num">
+                                      <p:cBhvr additive="base">
+                                        <p:cTn id="180" dur="500" fill="hold"/>
+                                        <p:tgtEl>
+                                          <p:spTgt spid="53"/>
+                                        </p:tgtEl>
+                                        <p:attrNameLst>
+                                          <p:attrName>ppt_x</p:attrName>
+                                        </p:attrNameLst>
+                                      </p:cBhvr>
+                                      <p:tavLst>
+                                        <p:tav tm="0">
+                                          <p:val>
+                                            <p:strVal val="#ppt_x"/>
+                                          </p:val>
+                                        </p:tav>
+                                        <p:tav tm="100000">
+                                          <p:val>
+                                            <p:strVal val="#ppt_x"/>
+                                          </p:val>
+                                        </p:tav>
+                                      </p:tavLst>
+                                    </p:anim>
+                                    <p:anim calcmode="lin" valueType="num">
+                                      <p:cBhvr additive="base">
+                                        <p:cTn id="181" dur="500" fill="hold"/>
+                                        <p:tgtEl>
+                                          <p:spTgt spid="53"/>
+                                        </p:tgtEl>
+                                        <p:attrNameLst>
+                                          <p:attrName>ppt_y</p:attrName>
+                                        </p:attrNameLst>
+                                      </p:cBhvr>
+                                      <p:tavLst>
+                                        <p:tav tm="0">
+                                          <p:val>
+                                            <p:strVal val="1+#ppt_h/2"/>
+                                          </p:val>
+                                        </p:tav>
+                                        <p:tav tm="100000">
+                                          <p:val>
+                                            <p:strVal val="#ppt_y"/>
+                                          </p:val>
+                                        </p:tav>
+                                      </p:tavLst>
+                                    </p:anim>
+                                  </p:childTnLst>
+                                </p:cTn>
+                              </p:par>
+                            </p:childTnLst>
+                          </p:cTn>
+                        </p:par>
+                      </p:childTnLst>
+                    </p:cTn>
+                  </p:par>
+                  <p:par>
+                    <p:cTn id="182" fill="hold">
+                      <p:stCondLst>
+                        <p:cond delay="indefinite"/>
+                      </p:stCondLst>
+                      <p:childTnLst>
+                        <p:par>
+                          <p:cTn id="183" fill="hold">
+                            <p:stCondLst>
+                              <p:cond delay="0"/>
+                            </p:stCondLst>
+                            <p:childTnLst>
+                              <p:par>
+                                <p:cTn id="184" presetID="2" presetClass="entr" presetSubtype="4" fill="hold" grpId="0" nodeType="clickEffect">
+                                  <p:stCondLst>
+                                    <p:cond delay="0"/>
+                                  </p:stCondLst>
+                                  <p:childTnLst>
+                                    <p:set>
+                                      <p:cBhvr>
+                                        <p:cTn id="185" dur="1" fill="hold">
+                                          <p:stCondLst>
+                                            <p:cond delay="0"/>
+                                          </p:stCondLst>
+                                        </p:cTn>
+                                        <p:tgtEl>
+                                          <p:spTgt spid="54"/>
+                                        </p:tgtEl>
+                                        <p:attrNameLst>
+                                          <p:attrName>style.visibility</p:attrName>
+                                        </p:attrNameLst>
+                                      </p:cBhvr>
+                                      <p:to>
+                                        <p:strVal val="visible"/>
+                                      </p:to>
+                                    </p:set>
+                                    <p:anim calcmode="lin" valueType="num">
+                                      <p:cBhvr additive="base">
+                                        <p:cTn id="186" dur="500" fill="hold"/>
+                                        <p:tgtEl>
+                                          <p:spTgt spid="54"/>
+                                        </p:tgtEl>
+                                        <p:attrNameLst>
+                                          <p:attrName>ppt_x</p:attrName>
+                                        </p:attrNameLst>
+                                      </p:cBhvr>
+                                      <p:tavLst>
+                                        <p:tav tm="0">
+                                          <p:val>
+                                            <p:strVal val="#ppt_x"/>
+                                          </p:val>
+                                        </p:tav>
+                                        <p:tav tm="100000">
+                                          <p:val>
+                                            <p:strVal val="#ppt_x"/>
+                                          </p:val>
+                                        </p:tav>
+                                      </p:tavLst>
+                                    </p:anim>
+                                    <p:anim calcmode="lin" valueType="num">
+                                      <p:cBhvr additive="base">
+                                        <p:cTn id="187" dur="500" fill="hold"/>
+                                        <p:tgtEl>
+                                          <p:spTgt spid="54"/>
+                                        </p:tgtEl>
+                                        <p:attrNameLst>
+                                          <p:attrName>ppt_y</p:attrName>
+                                        </p:attrNameLst>
+                                      </p:cBhvr>
+                                      <p:tavLst>
+                                        <p:tav tm="0">
+                                          <p:val>
+                                            <p:strVal val="1+#ppt_h/2"/>
+                                          </p:val>
+                                        </p:tav>
+                                        <p:tav tm="100000">
+                                          <p:val>
+                                            <p:strVal val="#ppt_y"/>
+                                          </p:val>
+                                        </p:tav>
+                                      </p:tavLst>
+                                    </p:anim>
+                                  </p:childTnLst>
+                                </p:cTn>
+                              </p:par>
+                            </p:childTnLst>
+                          </p:cTn>
+                        </p:par>
+                      </p:childTnLst>
+                    </p:cTn>
+                  </p:par>
                 </p:childTnLst>
               </p:cTn>
               <p:prevCondLst>
@@ -7305,6 +11739,32 @@
       <p:bldP spid="13" grpId="0" animBg="1"/>
       <p:bldP spid="14" grpId="0" animBg="1"/>
       <p:bldP spid="36" grpId="0" animBg="1"/>
+      <p:bldP spid="18" grpId="0" animBg="1"/>
+      <p:bldP spid="24" grpId="0" animBg="1"/>
+      <p:bldP spid="22" grpId="0" animBg="1"/>
+      <p:bldP spid="25" grpId="0" animBg="1"/>
+      <p:bldP spid="28" grpId="0" animBg="1"/>
+      <p:bldP spid="29" grpId="0" animBg="1"/>
+      <p:bldP spid="30" grpId="0" animBg="1"/>
+      <p:bldP spid="32" grpId="0" animBg="1"/>
+      <p:bldP spid="33" grpId="0" animBg="1"/>
+      <p:bldP spid="34" grpId="0" animBg="1"/>
+      <p:bldP spid="35" grpId="0" animBg="1"/>
+      <p:bldP spid="38" grpId="0" animBg="1"/>
+      <p:bldP spid="40" grpId="0" animBg="1"/>
+      <p:bldP spid="42" grpId="0" animBg="1"/>
+      <p:bldP spid="44" grpId="0" animBg="1"/>
+      <p:bldP spid="47" grpId="0" animBg="1"/>
+      <p:bldP spid="49" grpId="0" animBg="1"/>
+      <p:bldP spid="50" grpId="0" animBg="1"/>
+      <p:bldP spid="52" grpId="0" animBg="1"/>
+      <p:bldP spid="53" grpId="0" animBg="1"/>
+      <p:bldP spid="54" grpId="0" animBg="1"/>
+      <p:bldP spid="55" grpId="0" animBg="1"/>
+      <p:bldP spid="56" grpId="0" animBg="1"/>
+      <p:bldP spid="57" grpId="0" animBg="1"/>
+      <p:bldP spid="58" grpId="0" animBg="1"/>
+      <p:bldP spid="59" grpId="0" animBg="1"/>
     </p:bldLst>
   </p:timing>
 </p:sld>

</xml_diff>